<commit_message>
Drop Facebook and TikTok; All Things ODD socials in the deck too
The site now links only Instagram @allthingsodd.co, LinkedIn all-things-odd
and YouTube @all-things-odd. The deck template's contact slide carries the
same three (template .pptx rebuilt). B14 in the identity matrix marked done.

Co-Authored-By: Claude Opus 5.5 <noreply@anthropic.com>
</commit_message>
<xml_diff>
--- a/brand/deck/all-things-odd-template.pptx
+++ b/brand/deck/all-things-odd-template.pptx
@@ -3205,7 +3205,7 @@
       </p:grpSpPr>
       <p:pic>
         <p:nvPicPr>
-          <p:cNvPr id="2" name="Image 0" descr="/private/tmp/claude-501/-Users-ronnyeriksson/0feed94f-8961-4a6b-ba48-98aabd0b83f1/scratchpad/brand-wt/brand/deck/src/images/mosaic-01.jpg">    </p:cNvPr>
+          <p:cNvPr id="2" name="Image 0" descr="/private/tmp/claude-501/-Users-ronnyeriksson/6496d059-91c5-49f6-81ad-bd9a8ad802dd/scratchpad/socials-wt/brand/deck/src/images/mosaic-01.jpg">    </p:cNvPr>
           <p:cNvPicPr>
             <a:picLocks noChangeAspect="1"/>
           </p:cNvPicPr>
@@ -3229,7 +3229,7 @@
       </p:pic>
       <p:pic>
         <p:nvPicPr>
-          <p:cNvPr id="3" name="Image 1" descr="/private/tmp/claude-501/-Users-ronnyeriksson/0feed94f-8961-4a6b-ba48-98aabd0b83f1/scratchpad/brand-wt/brand/deck/src/images/mosaic-02.jpg">    </p:cNvPr>
+          <p:cNvPr id="3" name="Image 1" descr="/private/tmp/claude-501/-Users-ronnyeriksson/6496d059-91c5-49f6-81ad-bd9a8ad802dd/scratchpad/socials-wt/brand/deck/src/images/mosaic-02.jpg">    </p:cNvPr>
           <p:cNvPicPr>
             <a:picLocks noChangeAspect="1"/>
           </p:cNvPicPr>
@@ -3253,7 +3253,7 @@
       </p:pic>
       <p:pic>
         <p:nvPicPr>
-          <p:cNvPr id="4" name="Image 2" descr="/private/tmp/claude-501/-Users-ronnyeriksson/0feed94f-8961-4a6b-ba48-98aabd0b83f1/scratchpad/brand-wt/brand/deck/src/images/mosaic-03.jpg">    </p:cNvPr>
+          <p:cNvPr id="4" name="Image 2" descr="/private/tmp/claude-501/-Users-ronnyeriksson/6496d059-91c5-49f6-81ad-bd9a8ad802dd/scratchpad/socials-wt/brand/deck/src/images/mosaic-03.jpg">    </p:cNvPr>
           <p:cNvPicPr>
             <a:picLocks noChangeAspect="1"/>
           </p:cNvPicPr>
@@ -3277,7 +3277,7 @@
       </p:pic>
       <p:pic>
         <p:nvPicPr>
-          <p:cNvPr id="5" name="Image 3" descr="/private/tmp/claude-501/-Users-ronnyeriksson/0feed94f-8961-4a6b-ba48-98aabd0b83f1/scratchpad/brand-wt/brand/deck/src/images/mosaic-04.jpg">    </p:cNvPr>
+          <p:cNvPr id="5" name="Image 3" descr="/private/tmp/claude-501/-Users-ronnyeriksson/6496d059-91c5-49f6-81ad-bd9a8ad802dd/scratchpad/socials-wt/brand/deck/src/images/mosaic-04.jpg">    </p:cNvPr>
           <p:cNvPicPr>
             <a:picLocks noChangeAspect="1"/>
           </p:cNvPicPr>
@@ -3301,7 +3301,7 @@
       </p:pic>
       <p:pic>
         <p:nvPicPr>
-          <p:cNvPr id="6" name="Image 4" descr="/private/tmp/claude-501/-Users-ronnyeriksson/0feed94f-8961-4a6b-ba48-98aabd0b83f1/scratchpad/brand-wt/brand/deck/src/images/mosaic-05.jpg">    </p:cNvPr>
+          <p:cNvPr id="6" name="Image 4" descr="/private/tmp/claude-501/-Users-ronnyeriksson/6496d059-91c5-49f6-81ad-bd9a8ad802dd/scratchpad/socials-wt/brand/deck/src/images/mosaic-05.jpg">    </p:cNvPr>
           <p:cNvPicPr>
             <a:picLocks noChangeAspect="1"/>
           </p:cNvPicPr>
@@ -3325,7 +3325,7 @@
       </p:pic>
       <p:pic>
         <p:nvPicPr>
-          <p:cNvPr id="7" name="Image 5" descr="/private/tmp/claude-501/-Users-ronnyeriksson/0feed94f-8961-4a6b-ba48-98aabd0b83f1/scratchpad/brand-wt/brand/deck/src/images/mosaic-06.jpg">    </p:cNvPr>
+          <p:cNvPr id="7" name="Image 5" descr="/private/tmp/claude-501/-Users-ronnyeriksson/6496d059-91c5-49f6-81ad-bd9a8ad802dd/scratchpad/socials-wt/brand/deck/src/images/mosaic-06.jpg">    </p:cNvPr>
           <p:cNvPicPr>
             <a:picLocks noChangeAspect="1"/>
           </p:cNvPicPr>
@@ -3349,7 +3349,7 @@
       </p:pic>
       <p:pic>
         <p:nvPicPr>
-          <p:cNvPr id="8" name="Image 6" descr="/private/tmp/claude-501/-Users-ronnyeriksson/0feed94f-8961-4a6b-ba48-98aabd0b83f1/scratchpad/brand-wt/brand/deck/src/images/mosaic-07.jpg">    </p:cNvPr>
+          <p:cNvPr id="8" name="Image 6" descr="/private/tmp/claude-501/-Users-ronnyeriksson/6496d059-91c5-49f6-81ad-bd9a8ad802dd/scratchpad/socials-wt/brand/deck/src/images/mosaic-07.jpg">    </p:cNvPr>
           <p:cNvPicPr>
             <a:picLocks noChangeAspect="1"/>
           </p:cNvPicPr>
@@ -3373,7 +3373,7 @@
       </p:pic>
       <p:pic>
         <p:nvPicPr>
-          <p:cNvPr id="9" name="Image 7" descr="/private/tmp/claude-501/-Users-ronnyeriksson/0feed94f-8961-4a6b-ba48-98aabd0b83f1/scratchpad/brand-wt/brand/deck/src/images/mosaic-08.jpg">    </p:cNvPr>
+          <p:cNvPr id="9" name="Image 7" descr="/private/tmp/claude-501/-Users-ronnyeriksson/6496d059-91c5-49f6-81ad-bd9a8ad802dd/scratchpad/socials-wt/brand/deck/src/images/mosaic-08.jpg">    </p:cNvPr>
           <p:cNvPicPr>
             <a:picLocks noChangeAspect="1"/>
           </p:cNvPicPr>
@@ -3397,7 +3397,7 @@
       </p:pic>
       <p:pic>
         <p:nvPicPr>
-          <p:cNvPr id="10" name="Image 8" descr="/private/tmp/claude-501/-Users-ronnyeriksson/0feed94f-8961-4a6b-ba48-98aabd0b83f1/scratchpad/brand-wt/brand/deck/src/images/mosaic-09.jpg">    </p:cNvPr>
+          <p:cNvPr id="10" name="Image 8" descr="/private/tmp/claude-501/-Users-ronnyeriksson/6496d059-91c5-49f6-81ad-bd9a8ad802dd/scratchpad/socials-wt/brand/deck/src/images/mosaic-09.jpg">    </p:cNvPr>
           <p:cNvPicPr>
             <a:picLocks noChangeAspect="1"/>
           </p:cNvPicPr>
@@ -3421,7 +3421,7 @@
       </p:pic>
       <p:pic>
         <p:nvPicPr>
-          <p:cNvPr id="11" name="Image 9" descr="/private/tmp/claude-501/-Users-ronnyeriksson/0feed94f-8961-4a6b-ba48-98aabd0b83f1/scratchpad/brand-wt/brand/deck/src/images/mosaic-10.jpg">    </p:cNvPr>
+          <p:cNvPr id="11" name="Image 9" descr="/private/tmp/claude-501/-Users-ronnyeriksson/6496d059-91c5-49f6-81ad-bd9a8ad802dd/scratchpad/socials-wt/brand/deck/src/images/mosaic-10.jpg">    </p:cNvPr>
           <p:cNvPicPr>
             <a:picLocks noChangeAspect="1"/>
           </p:cNvPicPr>
@@ -3445,7 +3445,7 @@
       </p:pic>
       <p:pic>
         <p:nvPicPr>
-          <p:cNvPr id="12" name="Image 10" descr="/private/tmp/claude-501/-Users-ronnyeriksson/0feed94f-8961-4a6b-ba48-98aabd0b83f1/scratchpad/brand-wt/brand/deck/src/images/mosaic-11.jpg">    </p:cNvPr>
+          <p:cNvPr id="12" name="Image 10" descr="/private/tmp/claude-501/-Users-ronnyeriksson/6496d059-91c5-49f6-81ad-bd9a8ad802dd/scratchpad/socials-wt/brand/deck/src/images/mosaic-11.jpg">    </p:cNvPr>
           <p:cNvPicPr>
             <a:picLocks noChangeAspect="1"/>
           </p:cNvPicPr>
@@ -3469,7 +3469,7 @@
       </p:pic>
       <p:pic>
         <p:nvPicPr>
-          <p:cNvPr id="13" name="Image 11" descr="/private/tmp/claude-501/-Users-ronnyeriksson/0feed94f-8961-4a6b-ba48-98aabd0b83f1/scratchpad/brand-wt/brand/deck/src/images/mosaic-12.jpg">    </p:cNvPr>
+          <p:cNvPr id="13" name="Image 11" descr="/private/tmp/claude-501/-Users-ronnyeriksson/6496d059-91c5-49f6-81ad-bd9a8ad802dd/scratchpad/socials-wt/brand/deck/src/images/mosaic-12.jpg">    </p:cNvPr>
           <p:cNvPicPr>
             <a:picLocks noChangeAspect="1"/>
           </p:cNvPicPr>
@@ -3515,7 +3515,7 @@
       </p:sp>
       <p:pic>
         <p:nvPicPr>
-          <p:cNvPr id="15" name="Image 12" descr="/private/tmp/claude-501/-Users-ronnyeriksson/0feed94f-8961-4a6b-ba48-98aabd0b83f1/scratchpad/brand-wt/brand/logos/png/odd-mark-paper.png">    </p:cNvPr>
+          <p:cNvPr id="15" name="Image 12" descr="/private/tmp/claude-501/-Users-ronnyeriksson/6496d059-91c5-49f6-81ad-bd9a8ad802dd/scratchpad/socials-wt/brand/logos/png/odd-mark-paper.png">    </p:cNvPr>
           <p:cNvPicPr>
             <a:picLocks noChangeAspect="1"/>
           </p:cNvPicPr>
@@ -6020,7 +6020,7 @@
       </p:sp>
       <p:pic>
         <p:nvPicPr>
-          <p:cNvPr id="3" name="Image 0" descr="/private/tmp/claude-501/-Users-ronnyeriksson/0feed94f-8961-4a6b-ba48-98aabd0b83f1/scratchpad/brand-wt/brand/logos/png/odd-mark-paper.png">    </p:cNvPr>
+          <p:cNvPr id="3" name="Image 0" descr="/private/tmp/claude-501/-Users-ronnyeriksson/6496d059-91c5-49f6-81ad-bd9a8ad802dd/scratchpad/socials-wt/brand/logos/png/odd-mark-paper.png">    </p:cNvPr>
           <p:cNvPicPr>
             <a:picLocks noChangeAspect="1"/>
           </p:cNvPicPr>
@@ -6221,7 +6221,7 @@
       </p:sp>
       <p:pic>
         <p:nvPicPr>
-          <p:cNvPr id="11" name="Image 1" descr="/private/tmp/claude-501/-Users-ronnyeriksson/0feed94f-8961-4a6b-ba48-98aabd0b83f1/scratchpad/brand-wt/brand/logos/png/oddfest-paper.png">    </p:cNvPr>
+          <p:cNvPr id="11" name="Image 1" descr="/private/tmp/claude-501/-Users-ronnyeriksson/6496d059-91c5-49f6-81ad-bd9a8ad802dd/scratchpad/socials-wt/brand/logos/png/oddfest-paper.png">    </p:cNvPr>
           <p:cNvPicPr>
             <a:picLocks noChangeAspect="1"/>
           </p:cNvPicPr>
@@ -6349,7 +6349,7 @@
       </p:sp>
       <p:pic>
         <p:nvPicPr>
-          <p:cNvPr id="15" name="Image 2" descr="/private/tmp/claude-501/-Users-ronnyeriksson/0feed94f-8961-4a6b-ba48-98aabd0b83f1/scratchpad/brand-wt/brand/logos/png/oddference-paper.png">    </p:cNvPr>
+          <p:cNvPr id="15" name="Image 2" descr="/private/tmp/claude-501/-Users-ronnyeriksson/6496d059-91c5-49f6-81ad-bd9a8ad802dd/scratchpad/socials-wt/brand/logos/png/oddference-paper.png">    </p:cNvPr>
           <p:cNvPicPr>
             <a:picLocks noChangeAspect="1"/>
           </p:cNvPicPr>
@@ -6477,7 +6477,7 @@
       </p:sp>
       <p:pic>
         <p:nvPicPr>
-          <p:cNvPr id="19" name="Image 3" descr="/private/tmp/claude-501/-Users-ronnyeriksson/0feed94f-8961-4a6b-ba48-98aabd0b83f1/scratchpad/brand-wt/brand/logos/png/oddspace-paper.png">    </p:cNvPr>
+          <p:cNvPr id="19" name="Image 3" descr="/private/tmp/claude-501/-Users-ronnyeriksson/6496d059-91c5-49f6-81ad-bd9a8ad802dd/scratchpad/socials-wt/brand/logos/png/oddspace-paper.png">    </p:cNvPr>
           <p:cNvPicPr>
             <a:picLocks noChangeAspect="1"/>
           </p:cNvPicPr>
@@ -7043,7 +7043,7 @@
       </p:sp>
       <p:pic>
         <p:nvPicPr>
-          <p:cNvPr id="7" name="Image 0" descr="/private/tmp/claude-501/-Users-ronnyeriksson/0feed94f-8961-4a6b-ba48-98aabd0b83f1/scratchpad/brand-wt/brand/deck/src/images/partner-moomin.png">    </p:cNvPr>
+          <p:cNvPr id="7" name="Image 0" descr="/private/tmp/claude-501/-Users-ronnyeriksson/6496d059-91c5-49f6-81ad-bd9a8ad802dd/scratchpad/socials-wt/brand/deck/src/images/partner-moomin.png">    </p:cNvPr>
           <p:cNvPicPr>
             <a:picLocks noChangeAspect="1"/>
           </p:cNvPicPr>
@@ -7087,7 +7087,7 @@
       </p:sp>
       <p:pic>
         <p:nvPicPr>
-          <p:cNvPr id="9" name="Image 1" descr="/private/tmp/claude-501/-Users-ronnyeriksson/0feed94f-8961-4a6b-ba48-98aabd0b83f1/scratchpad/brand-wt/brand/deck/src/images/partner-genelec.png">    </p:cNvPr>
+          <p:cNvPr id="9" name="Image 1" descr="/private/tmp/claude-501/-Users-ronnyeriksson/6496d059-91c5-49f6-81ad-bd9a8ad802dd/scratchpad/socials-wt/brand/deck/src/images/partner-genelec.png">    </p:cNvPr>
           <p:cNvPicPr>
             <a:picLocks noChangeAspect="1"/>
           </p:cNvPicPr>
@@ -7131,7 +7131,7 @@
       </p:sp>
       <p:pic>
         <p:nvPicPr>
-          <p:cNvPr id="11" name="Image 2" descr="/private/tmp/claude-501/-Users-ronnyeriksson/0feed94f-8961-4a6b-ba48-98aabd0b83f1/scratchpad/brand-wt/brand/deck/src/images/partner-holvi.png">    </p:cNvPr>
+          <p:cNvPr id="11" name="Image 2" descr="/private/tmp/claude-501/-Users-ronnyeriksson/6496d059-91c5-49f6-81ad-bd9a8ad802dd/scratchpad/socials-wt/brand/deck/src/images/partner-holvi.png">    </p:cNvPr>
           <p:cNvPicPr>
             <a:picLocks noChangeAspect="1"/>
           </p:cNvPicPr>
@@ -7175,7 +7175,7 @@
       </p:sp>
       <p:pic>
         <p:nvPicPr>
-          <p:cNvPr id="13" name="Image 3" descr="/private/tmp/claude-501/-Users-ronnyeriksson/0feed94f-8961-4a6b-ba48-98aabd0b83f1/scratchpad/brand-wt/brand/deck/src/images/partner-tiketti.png">    </p:cNvPr>
+          <p:cNvPr id="13" name="Image 3" descr="/private/tmp/claude-501/-Users-ronnyeriksson/6496d059-91c5-49f6-81ad-bd9a8ad802dd/scratchpad/socials-wt/brand/deck/src/images/partner-tiketti.png">    </p:cNvPr>
           <p:cNvPicPr>
             <a:picLocks noChangeAspect="1"/>
           </p:cNvPicPr>
@@ -7219,7 +7219,7 @@
       </p:sp>
       <p:pic>
         <p:nvPicPr>
-          <p:cNvPr id="15" name="Image 4" descr="/private/tmp/claude-501/-Users-ronnyeriksson/0feed94f-8961-4a6b-ba48-98aabd0b83f1/scratchpad/brand-wt/brand/deck/src/images/partner-suomenkulttuurirahasto.png">    </p:cNvPr>
+          <p:cNvPr id="15" name="Image 4" descr="/private/tmp/claude-501/-Users-ronnyeriksson/6496d059-91c5-49f6-81ad-bd9a8ad802dd/scratchpad/socials-wt/brand/deck/src/images/partner-suomenkulttuurirahasto.png">    </p:cNvPr>
           <p:cNvPicPr>
             <a:picLocks noChangeAspect="1"/>
           </p:cNvPicPr>
@@ -7263,7 +7263,7 @@
       </p:sp>
       <p:pic>
         <p:nvPicPr>
-          <p:cNvPr id="17" name="Image 5" descr="/private/tmp/claude-501/-Users-ronnyeriksson/0feed94f-8961-4a6b-ba48-98aabd0b83f1/scratchpad/brand-wt/brand/deck/src/images/partner-suomenyrittajat.png">    </p:cNvPr>
+          <p:cNvPr id="17" name="Image 5" descr="/private/tmp/claude-501/-Users-ronnyeriksson/6496d059-91c5-49f6-81ad-bd9a8ad802dd/scratchpad/socials-wt/brand/deck/src/images/partner-suomenyrittajat.png">    </p:cNvPr>
           <p:cNvPicPr>
             <a:picLocks noChangeAspect="1"/>
           </p:cNvPicPr>
@@ -7307,7 +7307,7 @@
       </p:sp>
       <p:pic>
         <p:nvPicPr>
-          <p:cNvPr id="19" name="Image 6" descr="/private/tmp/claude-501/-Users-ronnyeriksson/0feed94f-8961-4a6b-ba48-98aabd0b83f1/scratchpad/brand-wt/brand/deck/src/images/partner-suomentekstiilijamuoti.png">    </p:cNvPr>
+          <p:cNvPr id="19" name="Image 6" descr="/private/tmp/claude-501/-Users-ronnyeriksson/6496d059-91c5-49f6-81ad-bd9a8ad802dd/scratchpad/socials-wt/brand/deck/src/images/partner-suomentekstiilijamuoti.png">    </p:cNvPr>
           <p:cNvPicPr>
             <a:picLocks noChangeAspect="1"/>
           </p:cNvPicPr>
@@ -7351,7 +7351,7 @@
       </p:sp>
       <p:pic>
         <p:nvPicPr>
-          <p:cNvPr id="21" name="Image 7" descr="/private/tmp/claude-501/-Users-ronnyeriksson/0feed94f-8961-4a6b-ba48-98aabd0b83f1/scratchpad/brand-wt/brand/deck/src/images/partner-yksityisyrittajansaatio.png">    </p:cNvPr>
+          <p:cNvPr id="21" name="Image 7" descr="/private/tmp/claude-501/-Users-ronnyeriksson/6496d059-91c5-49f6-81ad-bd9a8ad802dd/scratchpad/socials-wt/brand/deck/src/images/partner-yksityisyrittajansaatio.png">    </p:cNvPr>
           <p:cNvPicPr>
             <a:picLocks noChangeAspect="1"/>
           </p:cNvPicPr>
@@ -7395,7 +7395,7 @@
       </p:sp>
       <p:pic>
         <p:nvPicPr>
-          <p:cNvPr id="23" name="Image 8" descr="/private/tmp/claude-501/-Users-ronnyeriksson/0feed94f-8961-4a6b-ba48-98aabd0b83f1/scratchpad/brand-wt/brand/deck/src/images/partner-eit.png">    </p:cNvPr>
+          <p:cNvPr id="23" name="Image 8" descr="/private/tmp/claude-501/-Users-ronnyeriksson/6496d059-91c5-49f6-81ad-bd9a8ad802dd/scratchpad/socials-wt/brand/deck/src/images/partner-eit.png">    </p:cNvPr>
           <p:cNvPicPr>
             <a:picLocks noChangeAspect="1"/>
           </p:cNvPicPr>
@@ -7439,7 +7439,7 @@
       </p:sp>
       <p:pic>
         <p:nvPicPr>
-          <p:cNvPr id="25" name="Image 9" descr="/private/tmp/claude-501/-Users-ronnyeriksson/0feed94f-8961-4a6b-ba48-98aabd0b83f1/scratchpad/brand-wt/brand/deck/src/images/partner-lasipalatsikortteli.png">    </p:cNvPr>
+          <p:cNvPr id="25" name="Image 9" descr="/private/tmp/claude-501/-Users-ronnyeriksson/6496d059-91c5-49f6-81ad-bd9a8ad802dd/scratchpad/socials-wt/brand/deck/src/images/partner-lasipalatsikortteli.png">    </p:cNvPr>
           <p:cNvPicPr>
             <a:picLocks noChangeAspect="1"/>
           </p:cNvPicPr>
@@ -7483,7 +7483,7 @@
       </p:sp>
       <p:pic>
         <p:nvPicPr>
-          <p:cNvPr id="27" name="Image 10" descr="/private/tmp/claude-501/-Users-ronnyeriksson/0feed94f-8961-4a6b-ba48-98aabd0b83f1/scratchpad/brand-wt/brand/deck/src/images/partner-kauppakamari.png">    </p:cNvPr>
+          <p:cNvPr id="27" name="Image 10" descr="/private/tmp/claude-501/-Users-ronnyeriksson/6496d059-91c5-49f6-81ad-bd9a8ad802dd/scratchpad/socials-wt/brand/deck/src/images/partner-kauppakamari.png">    </p:cNvPr>
           <p:cNvPicPr>
             <a:picLocks noChangeAspect="1"/>
           </p:cNvPicPr>
@@ -7527,7 +7527,7 @@
       </p:sp>
       <p:pic>
         <p:nvPicPr>
-          <p:cNvPr id="29" name="Image 11" descr="/private/tmp/claude-501/-Users-ronnyeriksson/0feed94f-8961-4a6b-ba48-98aabd0b83f1/scratchpad/brand-wt/brand/deck/src/images/partner-helsinkiplayground.png">    </p:cNvPr>
+          <p:cNvPr id="29" name="Image 11" descr="/private/tmp/claude-501/-Users-ronnyeriksson/6496d059-91c5-49f6-81ad-bd9a8ad802dd/scratchpad/socials-wt/brand/deck/src/images/partner-helsinkiplayground.png">    </p:cNvPr>
           <p:cNvPicPr>
             <a:picLocks noChangeAspect="1"/>
           </p:cNvPicPr>
@@ -7571,7 +7571,7 @@
       </p:sp>
       <p:pic>
         <p:nvPicPr>
-          <p:cNvPr id="31" name="Image 12" descr="/private/tmp/claude-501/-Users-ronnyeriksson/0feed94f-8961-4a6b-ba48-98aabd0b83f1/scratchpad/brand-wt/brand/deck/src/images/partner-helsinkicasting.png">    </p:cNvPr>
+          <p:cNvPr id="31" name="Image 12" descr="/private/tmp/claude-501/-Users-ronnyeriksson/6496d059-91c5-49f6-81ad-bd9a8ad802dd/scratchpad/socials-wt/brand/deck/src/images/partner-helsinkicasting.png">    </p:cNvPr>
           <p:cNvPicPr>
             <a:picLocks noChangeAspect="1"/>
           </p:cNvPicPr>
@@ -7615,7 +7615,7 @@
       </p:sp>
       <p:pic>
         <p:nvPicPr>
-          <p:cNvPr id="33" name="Image 13" descr="/private/tmp/claude-501/-Users-ronnyeriksson/0feed94f-8961-4a6b-ba48-98aabd0b83f1/scratchpad/brand-wt/brand/deck/src/images/partner-radicalcreativity.png">    </p:cNvPr>
+          <p:cNvPr id="33" name="Image 13" descr="/private/tmp/claude-501/-Users-ronnyeriksson/6496d059-91c5-49f6-81ad-bd9a8ad802dd/scratchpad/socials-wt/brand/deck/src/images/partner-radicalcreativity.png">    </p:cNvPr>
           <p:cNvPicPr>
             <a:picLocks noChangeAspect="1"/>
           </p:cNvPicPr>
@@ -7659,7 +7659,7 @@
       </p:sp>
       <p:pic>
         <p:nvPicPr>
-          <p:cNvPr id="35" name="Image 14" descr="/private/tmp/claude-501/-Users-ronnyeriksson/0feed94f-8961-4a6b-ba48-98aabd0b83f1/scratchpad/brand-wt/brand/deck/src/images/partner-adventureclub.png">    </p:cNvPr>
+          <p:cNvPr id="35" name="Image 14" descr="/private/tmp/claude-501/-Users-ronnyeriksson/6496d059-91c5-49f6-81ad-bd9a8ad802dd/scratchpad/socials-wt/brand/deck/src/images/partner-adventureclub.png">    </p:cNvPr>
           <p:cNvPicPr>
             <a:picLocks noChangeAspect="1"/>
           </p:cNvPicPr>
@@ -7703,7 +7703,7 @@
       </p:sp>
       <p:pic>
         <p:nvPicPr>
-          <p:cNvPr id="37" name="Image 15" descr="/private/tmp/claude-501/-Users-ronnyeriksson/0feed94f-8961-4a6b-ba48-98aabd0b83f1/scratchpad/brand-wt/brand/deck/src/images/partner-prodjfinland.png">    </p:cNvPr>
+          <p:cNvPr id="37" name="Image 15" descr="/private/tmp/claude-501/-Users-ronnyeriksson/6496d059-91c5-49f6-81ad-bd9a8ad802dd/scratchpad/socials-wt/brand/deck/src/images/partner-prodjfinland.png">    </p:cNvPr>
           <p:cNvPicPr>
             <a:picLocks noChangeAspect="1"/>
           </p:cNvPicPr>
@@ -7747,7 +7747,7 @@
       </p:sp>
       <p:pic>
         <p:nvPicPr>
-          <p:cNvPr id="39" name="Image 16" descr="/private/tmp/claude-501/-Users-ronnyeriksson/0feed94f-8961-4a6b-ba48-98aabd0b83f1/scratchpad/brand-wt/brand/deck/src/images/partner-dottir.png">    </p:cNvPr>
+          <p:cNvPr id="39" name="Image 16" descr="/private/tmp/claude-501/-Users-ronnyeriksson/6496d059-91c5-49f6-81ad-bd9a8ad802dd/scratchpad/socials-wt/brand/deck/src/images/partner-dottir.png">    </p:cNvPr>
           <p:cNvPicPr>
             <a:picLocks noChangeAspect="1"/>
           </p:cNvPicPr>
@@ -7791,7 +7791,7 @@
       </p:sp>
       <p:pic>
         <p:nvPicPr>
-          <p:cNvPr id="41" name="Image 17" descr="/private/tmp/claude-501/-Users-ronnyeriksson/0feed94f-8961-4a6b-ba48-98aabd0b83f1/scratchpad/brand-wt/brand/deck/src/images/partner-liwlig.png">    </p:cNvPr>
+          <p:cNvPr id="41" name="Image 17" descr="/private/tmp/claude-501/-Users-ronnyeriksson/6496d059-91c5-49f6-81ad-bd9a8ad802dd/scratchpad/socials-wt/brand/deck/src/images/partner-liwlig.png">    </p:cNvPr>
           <p:cNvPicPr>
             <a:picLocks noChangeAspect="1"/>
           </p:cNvPicPr>
@@ -7835,7 +7835,7 @@
       </p:sp>
       <p:pic>
         <p:nvPicPr>
-          <p:cNvPr id="43" name="Image 18" descr="/private/tmp/claude-501/-Users-ronnyeriksson/0feed94f-8961-4a6b-ba48-98aabd0b83f1/scratchpad/brand-wt/brand/deck/src/images/partner-latorrefazione.png">    </p:cNvPr>
+          <p:cNvPr id="43" name="Image 18" descr="/private/tmp/claude-501/-Users-ronnyeriksson/6496d059-91c5-49f6-81ad-bd9a8ad802dd/scratchpad/socials-wt/brand/deck/src/images/partner-latorrefazione.png">    </p:cNvPr>
           <p:cNvPicPr>
             <a:picLocks noChangeAspect="1"/>
           </p:cNvPicPr>
@@ -7879,7 +7879,7 @@
       </p:sp>
       <p:pic>
         <p:nvPicPr>
-          <p:cNvPr id="45" name="Image 19" descr="/private/tmp/claude-501/-Users-ronnyeriksson/0feed94f-8961-4a6b-ba48-98aabd0b83f1/scratchpad/brand-wt/brand/deck/src/images/partner-uneton.png">    </p:cNvPr>
+          <p:cNvPr id="45" name="Image 19" descr="/private/tmp/claude-501/-Users-ronnyeriksson/6496d059-91c5-49f6-81ad-bd9a8ad802dd/scratchpad/socials-wt/brand/deck/src/images/partner-uneton.png">    </p:cNvPr>
           <p:cNvPicPr>
             <a:picLocks noChangeAspect="1"/>
           </p:cNvPicPr>
@@ -7923,7 +7923,7 @@
       </p:sp>
       <p:pic>
         <p:nvPicPr>
-          <p:cNvPr id="47" name="Image 20" descr="/private/tmp/claude-501/-Users-ronnyeriksson/0feed94f-8961-4a6b-ba48-98aabd0b83f1/scratchpad/brand-wt/brand/deck/src/images/partner-sanfrancisco.png">    </p:cNvPr>
+          <p:cNvPr id="47" name="Image 20" descr="/private/tmp/claude-501/-Users-ronnyeriksson/6496d059-91c5-49f6-81ad-bd9a8ad802dd/scratchpad/socials-wt/brand/deck/src/images/partner-sanfrancisco.png">    </p:cNvPr>
           <p:cNvPicPr>
             <a:picLocks noChangeAspect="1"/>
           </p:cNvPicPr>
@@ -7967,7 +7967,7 @@
       </p:sp>
       <p:pic>
         <p:nvPicPr>
-          <p:cNvPr id="49" name="Image 21" descr="/private/tmp/claude-501/-Users-ronnyeriksson/0feed94f-8961-4a6b-ba48-98aabd0b83f1/scratchpad/brand-wt/brand/deck/src/images/partner-tresmeder.png">    </p:cNvPr>
+          <p:cNvPr id="49" name="Image 21" descr="/private/tmp/claude-501/-Users-ronnyeriksson/6496d059-91c5-49f6-81ad-bd9a8ad802dd/scratchpad/socials-wt/brand/deck/src/images/partner-tresmeder.png">    </p:cNvPr>
           <p:cNvPicPr>
             <a:picLocks noChangeAspect="1"/>
           </p:cNvPicPr>
@@ -8275,7 +8275,7 @@
       </p:sp>
       <p:pic>
         <p:nvPicPr>
-          <p:cNvPr id="7" name="Image 0" descr="/private/tmp/claude-501/-Users-ronnyeriksson/0feed94f-8961-4a6b-ba48-98aabd0b83f1/scratchpad/brand-wt/brand/deck/src/images/speaker-sanna-kaisa-niikko.jpg">    </p:cNvPr>
+          <p:cNvPr id="7" name="Image 0" descr="/private/tmp/claude-501/-Users-ronnyeriksson/6496d059-91c5-49f6-81ad-bd9a8ad802dd/scratchpad/socials-wt/brand/deck/src/images/speaker-sanna-kaisa-niikko.jpg">    </p:cNvPr>
           <p:cNvPicPr>
             <a:picLocks noChangeAspect="1"/>
           </p:cNvPicPr>
@@ -8403,7 +8403,7 @@
       </p:sp>
       <p:pic>
         <p:nvPicPr>
-          <p:cNvPr id="11" name="Image 1" descr="/private/tmp/claude-501/-Users-ronnyeriksson/0feed94f-8961-4a6b-ba48-98aabd0b83f1/scratchpad/brand-wt/brand/deck/src/images/speaker-siamak-naghian.jpg">    </p:cNvPr>
+          <p:cNvPr id="11" name="Image 1" descr="/private/tmp/claude-501/-Users-ronnyeriksson/6496d059-91c5-49f6-81ad-bd9a8ad802dd/scratchpad/socials-wt/brand/deck/src/images/speaker-siamak-naghian.jpg">    </p:cNvPr>
           <p:cNvPicPr>
             <a:picLocks noChangeAspect="1"/>
           </p:cNvPicPr>
@@ -8531,7 +8531,7 @@
       </p:sp>
       <p:pic>
         <p:nvPicPr>
-          <p:cNvPr id="15" name="Image 2" descr="/private/tmp/claude-501/-Users-ronnyeriksson/0feed94f-8961-4a6b-ba48-98aabd0b83f1/scratchpad/brand-wt/brand/deck/src/images/speaker-ashley-jex-wagner.jpg">    </p:cNvPr>
+          <p:cNvPr id="15" name="Image 2" descr="/private/tmp/claude-501/-Users-ronnyeriksson/6496d059-91c5-49f6-81ad-bd9a8ad802dd/scratchpad/socials-wt/brand/deck/src/images/speaker-ashley-jex-wagner.jpg">    </p:cNvPr>
           <p:cNvPicPr>
             <a:picLocks noChangeAspect="1"/>
           </p:cNvPicPr>
@@ -8659,7 +8659,7 @@
       </p:sp>
       <p:pic>
         <p:nvPicPr>
-          <p:cNvPr id="19" name="Image 3" descr="/private/tmp/claude-501/-Users-ronnyeriksson/0feed94f-8961-4a6b-ba48-98aabd0b83f1/scratchpad/brand-wt/brand/deck/src/images/speaker-atte-jaaskelainen.jpg">    </p:cNvPr>
+          <p:cNvPr id="19" name="Image 3" descr="/private/tmp/claude-501/-Users-ronnyeriksson/6496d059-91c5-49f6-81ad-bd9a8ad802dd/scratchpad/socials-wt/brand/deck/src/images/speaker-atte-jaaskelainen.jpg">    </p:cNvPr>
           <p:cNvPicPr>
             <a:picLocks noChangeAspect="1"/>
           </p:cNvPicPr>
@@ -8787,7 +8787,7 @@
       </p:sp>
       <p:pic>
         <p:nvPicPr>
-          <p:cNvPr id="23" name="Image 4" descr="/private/tmp/claude-501/-Users-ronnyeriksson/0feed94f-8961-4a6b-ba48-98aabd0b83f1/scratchpad/brand-wt/brand/deck/src/images/speaker-perttu-polonen.jpg">    </p:cNvPr>
+          <p:cNvPr id="23" name="Image 4" descr="/private/tmp/claude-501/-Users-ronnyeriksson/6496d059-91c5-49f6-81ad-bd9a8ad802dd/scratchpad/socials-wt/brand/deck/src/images/speaker-perttu-polonen.jpg">    </p:cNvPr>
           <p:cNvPicPr>
             <a:picLocks noChangeAspect="1"/>
           </p:cNvPicPr>
@@ -8915,7 +8915,7 @@
       </p:sp>
       <p:pic>
         <p:nvPicPr>
-          <p:cNvPr id="27" name="Image 5" descr="/private/tmp/claude-501/-Users-ronnyeriksson/0feed94f-8961-4a6b-ba48-98aabd0b83f1/scratchpad/brand-wt/brand/deck/src/images/speaker-galit-ariel.jpg">    </p:cNvPr>
+          <p:cNvPr id="27" name="Image 5" descr="/private/tmp/claude-501/-Users-ronnyeriksson/6496d059-91c5-49f6-81ad-bd9a8ad802dd/scratchpad/socials-wt/brand/deck/src/images/speaker-galit-ariel.jpg">    </p:cNvPr>
           <p:cNvPicPr>
             <a:picLocks noChangeAspect="1"/>
           </p:cNvPicPr>
@@ -9043,7 +9043,7 @@
       </p:sp>
       <p:pic>
         <p:nvPicPr>
-          <p:cNvPr id="31" name="Image 6" descr="/private/tmp/claude-501/-Users-ronnyeriksson/0feed94f-8961-4a6b-ba48-98aabd0b83f1/scratchpad/brand-wt/brand/deck/src/images/speaker-alf-rehn.jpg">    </p:cNvPr>
+          <p:cNvPr id="31" name="Image 6" descr="/private/tmp/claude-501/-Users-ronnyeriksson/6496d059-91c5-49f6-81ad-bd9a8ad802dd/scratchpad/socials-wt/brand/deck/src/images/speaker-alf-rehn.jpg">    </p:cNvPr>
           <p:cNvPicPr>
             <a:picLocks noChangeAspect="1"/>
           </p:cNvPicPr>
@@ -9171,7 +9171,7 @@
       </p:sp>
       <p:pic>
         <p:nvPicPr>
-          <p:cNvPr id="35" name="Image 7" descr="/private/tmp/claude-501/-Users-ronnyeriksson/0feed94f-8961-4a6b-ba48-98aabd0b83f1/scratchpad/brand-wt/brand/deck/src/images/speaker-rolf-ekroth.jpg">    </p:cNvPr>
+          <p:cNvPr id="35" name="Image 7" descr="/private/tmp/claude-501/-Users-ronnyeriksson/6496d059-91c5-49f6-81ad-bd9a8ad802dd/scratchpad/socials-wt/brand/deck/src/images/speaker-rolf-ekroth.jpg">    </p:cNvPr>
           <p:cNvPicPr>
             <a:picLocks noChangeAspect="1"/>
           </p:cNvPicPr>
@@ -9299,7 +9299,7 @@
       </p:sp>
       <p:pic>
         <p:nvPicPr>
-          <p:cNvPr id="39" name="Image 8" descr="/private/tmp/claude-501/-Users-ronnyeriksson/0feed94f-8961-4a6b-ba48-98aabd0b83f1/scratchpad/brand-wt/brand/deck/src/images/speaker-samppa-lappalainen.jpg">    </p:cNvPr>
+          <p:cNvPr id="39" name="Image 8" descr="/private/tmp/claude-501/-Users-ronnyeriksson/6496d059-91c5-49f6-81ad-bd9a8ad802dd/scratchpad/socials-wt/brand/deck/src/images/speaker-samppa-lappalainen.jpg">    </p:cNvPr>
           <p:cNvPicPr>
             <a:picLocks noChangeAspect="1"/>
           </p:cNvPicPr>
@@ -9427,7 +9427,7 @@
       </p:sp>
       <p:pic>
         <p:nvPicPr>
-          <p:cNvPr id="43" name="Image 9" descr="/private/tmp/claude-501/-Users-ronnyeriksson/0feed94f-8961-4a6b-ba48-98aabd0b83f1/scratchpad/brand-wt/brand/deck/src/images/speaker-anna-brchisky.jpg">    </p:cNvPr>
+          <p:cNvPr id="43" name="Image 9" descr="/private/tmp/claude-501/-Users-ronnyeriksson/6496d059-91c5-49f6-81ad-bd9a8ad802dd/scratchpad/socials-wt/brand/deck/src/images/speaker-anna-brchisky.jpg">    </p:cNvPr>
           <p:cNvPicPr>
             <a:picLocks noChangeAspect="1"/>
           </p:cNvPicPr>
@@ -10619,7 +10619,7 @@
       </p:sp>
       <p:pic>
         <p:nvPicPr>
-          <p:cNvPr id="3" name="Image 0" descr="/private/tmp/claude-501/-Users-ronnyeriksson/0feed94f-8961-4a6b-ba48-98aabd0b83f1/scratchpad/brand-wt/brand/deck/src/images/case-odd-deep-space.jpg">    </p:cNvPr>
+          <p:cNvPr id="3" name="Image 0" descr="/private/tmp/claude-501/-Users-ronnyeriksson/6496d059-91c5-49f6-81ad-bd9a8ad802dd/scratchpad/socials-wt/brand/deck/src/images/case-odd-deep-space.jpg">    </p:cNvPr>
           <p:cNvPicPr>
             <a:picLocks noChangeAspect="1"/>
           </p:cNvPicPr>
@@ -10982,7 +10982,7 @@
       </p:sp>
       <p:pic>
         <p:nvPicPr>
-          <p:cNvPr id="3" name="Image 0" descr="/private/tmp/claude-501/-Users-ronnyeriksson/0feed94f-8961-4a6b-ba48-98aabd0b83f1/scratchpad/brand-wt/brand/deck/src/images/strip-creative.jpg">    </p:cNvPr>
+          <p:cNvPr id="3" name="Image 0" descr="/private/tmp/claude-501/-Users-ronnyeriksson/6496d059-91c5-49f6-81ad-bd9a8ad802dd/scratchpad/socials-wt/brand/deck/src/images/strip-creative.jpg">    </p:cNvPr>
           <p:cNvPicPr>
             <a:picLocks noChangeAspect="1"/>
           </p:cNvPicPr>
@@ -11006,7 +11006,7 @@
       </p:pic>
       <p:pic>
         <p:nvPicPr>
-          <p:cNvPr id="4" name="Image 1" descr="/private/tmp/claude-501/-Users-ronnyeriksson/0feed94f-8961-4a6b-ba48-98aabd0b83f1/scratchpad/brand-wt/brand/deck/src/images/strip-business.jpg">    </p:cNvPr>
+          <p:cNvPr id="4" name="Image 1" descr="/private/tmp/claude-501/-Users-ronnyeriksson/6496d059-91c5-49f6-81ad-bd9a8ad802dd/scratchpad/socials-wt/brand/deck/src/images/strip-business.jpg">    </p:cNvPr>
           <p:cNvPicPr>
             <a:picLocks noChangeAspect="1"/>
           </p:cNvPicPr>
@@ -12006,7 +12006,7 @@
       </p:grpSpPr>
       <p:pic>
         <p:nvPicPr>
-          <p:cNvPr id="2" name="Image 0" descr="/private/tmp/claude-501/-Users-ronnyeriksson/0feed94f-8961-4a6b-ba48-98aabd0b83f1/scratchpad/brand-wt/brand/logos/png/odd-mark-ink.png">    </p:cNvPr>
+          <p:cNvPr id="2" name="Image 0" descr="/private/tmp/claude-501/-Users-ronnyeriksson/6496d059-91c5-49f6-81ad-bd9a8ad802dd/scratchpad/socials-wt/brand/logos/png/odd-mark-ink.png">    </p:cNvPr>
           <p:cNvPicPr>
             <a:picLocks noChangeAspect="1"/>
           </p:cNvPicPr>
@@ -12313,7 +12313,7 @@
       </p:sp>
       <p:pic>
         <p:nvPicPr>
-          <p:cNvPr id="3" name="Image 0" descr="/private/tmp/claude-501/-Users-ronnyeriksson/0feed94f-8961-4a6b-ba48-98aabd0b83f1/scratchpad/brand-wt/brand/logos/png/odd-mark-ink.png">    </p:cNvPr>
+          <p:cNvPr id="3" name="Image 0" descr="/private/tmp/claude-501/-Users-ronnyeriksson/6496d059-91c5-49f6-81ad-bd9a8ad802dd/scratchpad/socials-wt/brand/logos/png/odd-mark-ink.png">    </p:cNvPr>
           <p:cNvPicPr>
             <a:picLocks noChangeAspect="1"/>
           </p:cNvPicPr>
@@ -12891,7 +12891,7 @@
                 <a:ea typeface="Gabarito" pitchFamily="34" charset="-122"/>
                 <a:cs typeface="Gabarito" pitchFamily="34" charset="-120"/>
               </a:rPr>
-              <a:t>@oddfest.fi</a:t>
+              <a:t>@allthingsodd.co</a:t>
             </a:r>
             <a:endParaRPr lang="en-US" sz="1800" dirty="0"/>
           </a:p>
@@ -12998,7 +12998,7 @@
                 <a:ea typeface="Gabarito" pitchFamily="34" charset="-122"/>
                 <a:cs typeface="Gabarito" pitchFamily="34" charset="-120"/>
               </a:rPr>
-              <a:t>linkedin.com/company/oddfest</a:t>
+              <a:t>linkedin.com/company/all-things-odd</a:t>
             </a:r>
             <a:endParaRPr lang="en-US" sz="1800" dirty="0"/>
           </a:p>
@@ -13063,7 +13063,7 @@
                 <a:ea typeface="Gabarito SemiBold" pitchFamily="34" charset="-122"/>
                 <a:cs typeface="Gabarito SemiBold" pitchFamily="34" charset="-120"/>
               </a:rPr>
-              <a:t>NEWSLETTER</a:t>
+              <a:t>YOUTUBE</a:t>
             </a:r>
             <a:endParaRPr lang="en-US" sz="1400" dirty="0"/>
           </a:p>
@@ -13105,7 +13105,7 @@
                 <a:ea typeface="Gabarito" pitchFamily="34" charset="-122"/>
                 <a:cs typeface="Gabarito" pitchFamily="34" charset="-120"/>
               </a:rPr>
-              <a:t>oddfest.beehiiv.com</a:t>
+              <a:t>youtube.com/@all-things-odd</a:t>
             </a:r>
             <a:endParaRPr lang="en-US" sz="1800" dirty="0"/>
           </a:p>
@@ -13137,6 +13137,113 @@
       <p:sp>
         <p:nvSpPr>
           <p:cNvPr id="26" name="Text 23"/>
+          <p:cNvSpPr txBox="1"/>
+          <p:nvPr/>
+        </p:nvSpPr>
+        <p:spPr>
+          <a:xfrm>
+            <a:off x="6210148" y="5312664"/>
+            <a:ext cx="1650949" cy="201168"/>
+          </a:xfrm>
+          <a:prstGeom prst="rect">
+            <a:avLst/>
+          </a:prstGeom>
+          <a:noFill/>
+          <a:ln/>
+        </p:spPr>
+        <p:txBody>
+          <a:bodyPr wrap="square" lIns="0" tIns="0" rIns="0" bIns="0" rtlCol="0" anchor="t"/>
+          <a:lstStyle/>
+          <a:p>
+            <a:pPr algn="l" indent="0" marL="0">
+              <a:lnSpc>
+                <a:spcPts val="1900"/>
+              </a:lnSpc>
+              <a:buNone/>
+            </a:pPr>
+            <a:r>
+              <a:rPr lang="en-US" sz="1400" spc="220" kern="0" dirty="0">
+                <a:solidFill>
+                  <a:srgbClr val="5F5A5B"/>
+                </a:solidFill>
+                <a:latin typeface="Gabarito SemiBold" pitchFamily="34" charset="0"/>
+                <a:ea typeface="Gabarito SemiBold" pitchFamily="34" charset="-122"/>
+                <a:cs typeface="Gabarito SemiBold" pitchFamily="34" charset="-120"/>
+              </a:rPr>
+              <a:t>NEWSLETTER</a:t>
+            </a:r>
+            <a:endParaRPr lang="en-US" sz="1400" dirty="0"/>
+          </a:p>
+        </p:txBody>
+      </p:sp>
+      <p:sp>
+        <p:nvSpPr>
+          <p:cNvPr id="27" name="Text 24"/>
+          <p:cNvSpPr txBox="1"/>
+          <p:nvPr/>
+        </p:nvSpPr>
+        <p:spPr>
+          <a:xfrm>
+            <a:off x="8089697" y="5276088"/>
+            <a:ext cx="3530498" cy="274320"/>
+          </a:xfrm>
+          <a:prstGeom prst="rect">
+            <a:avLst/>
+          </a:prstGeom>
+          <a:noFill/>
+          <a:ln/>
+        </p:spPr>
+        <p:txBody>
+          <a:bodyPr wrap="square" lIns="0" tIns="0" rIns="0" bIns="0" rtlCol="0" anchor="t"/>
+          <a:lstStyle/>
+          <a:p>
+            <a:pPr indent="0" marL="0">
+              <a:lnSpc>
+                <a:spcPts val="2500"/>
+              </a:lnSpc>
+              <a:buNone/>
+            </a:pPr>
+            <a:r>
+              <a:rPr lang="en-US" sz="1800" dirty="0">
+                <a:solidFill>
+                  <a:srgbClr val="0E090B"/>
+                </a:solidFill>
+                <a:latin typeface="Gabarito" pitchFamily="34" charset="0"/>
+                <a:ea typeface="Gabarito" pitchFamily="34" charset="-122"/>
+                <a:cs typeface="Gabarito" pitchFamily="34" charset="-120"/>
+              </a:rPr>
+              <a:t>oddfest.beehiiv.com</a:t>
+            </a:r>
+            <a:endParaRPr lang="en-US" sz="1800" dirty="0"/>
+          </a:p>
+        </p:txBody>
+      </p:sp>
+      <p:sp>
+        <p:nvSpPr>
+          <p:cNvPr id="28" name="Shape 25"/>
+          <p:cNvSpPr/>
+          <p:nvPr/>
+        </p:nvSpPr>
+        <p:spPr>
+          <a:xfrm>
+            <a:off x="6210148" y="5751576"/>
+            <a:ext cx="5410048" cy="0"/>
+          </a:xfrm>
+          <a:prstGeom prst="line">
+            <a:avLst/>
+          </a:prstGeom>
+          <a:noFill/>
+          <a:ln w="9525">
+            <a:solidFill>
+              <a:srgbClr val="C9C5C5"/>
+            </a:solidFill>
+            <a:prstDash val="solid"/>
+          </a:ln>
+        </p:spPr>
+      </p:sp>
+      <p:sp>
+        <p:nvSpPr>
+          <p:cNvPr id="29" name="Text 26"/>
           <p:cNvSpPr txBox="1"/>
           <p:nvPr/>
         </p:nvSpPr>
@@ -13609,7 +13716,7 @@
       </p:sp>
       <p:pic>
         <p:nvPicPr>
-          <p:cNvPr id="3" name="Image 0" descr="/private/tmp/claude-501/-Users-ronnyeriksson/0feed94f-8961-4a6b-ba48-98aabd0b83f1/scratchpad/brand-wt/brand/logos/png/odd-mark-paper.png">    </p:cNvPr>
+          <p:cNvPr id="3" name="Image 0" descr="/private/tmp/claude-501/-Users-ronnyeriksson/6496d059-91c5-49f6-81ad-bd9a8ad802dd/scratchpad/socials-wt/brand/logos/png/odd-mark-paper.png">    </p:cNvPr>
           <p:cNvPicPr>
             <a:picLocks noChangeAspect="1"/>
           </p:cNvPicPr>
@@ -14327,7 +14434,7 @@
       </p:sp>
       <p:pic>
         <p:nvPicPr>
-          <p:cNvPr id="3" name="Image 0" descr="/private/tmp/claude-501/-Users-ronnyeriksson/0feed94f-8961-4a6b-ba48-98aabd0b83f1/scratchpad/brand-wt/brand/deck/src/images/oddfest-oddtheatre.jpg">    </p:cNvPr>
+          <p:cNvPr id="3" name="Image 0" descr="/private/tmp/claude-501/-Users-ronnyeriksson/6496d059-91c5-49f6-81ad-bd9a8ad802dd/scratchpad/socials-wt/brand/deck/src/images/oddfest-oddtheatre.jpg">    </p:cNvPr>
           <p:cNvPicPr>
             <a:picLocks noChangeAspect="1"/>
           </p:cNvPicPr>
@@ -14642,7 +14749,7 @@
       </p:sp>
       <p:pic>
         <p:nvPicPr>
-          <p:cNvPr id="3" name="Image 0" descr="/private/tmp/claude-501/-Users-ronnyeriksson/0feed94f-8961-4a6b-ba48-98aabd0b83f1/scratchpad/brand-wt/brand/deck/src/images/oddference-stage.jpg">    </p:cNvPr>
+          <p:cNvPr id="3" name="Image 0" descr="/private/tmp/claude-501/-Users-ronnyeriksson/6496d059-91c5-49f6-81ad-bd9a8ad802dd/scratchpad/socials-wt/brand/deck/src/images/oddference-stage.jpg">    </p:cNvPr>
           <p:cNvPicPr>
             <a:picLocks noChangeAspect="1"/>
           </p:cNvPicPr>
@@ -14898,7 +15005,7 @@
       </p:grpSpPr>
       <p:pic>
         <p:nvPicPr>
-          <p:cNvPr id="2" name="Image 0" descr="/private/tmp/claude-501/-Users-ronnyeriksson/0feed94f-8961-4a6b-ba48-98aabd0b83f1/scratchpad/brand-wt/brand/deck/src/images/fullbleed-valerie-june.jpg">    </p:cNvPr>
+          <p:cNvPr id="2" name="Image 0" descr="/private/tmp/claude-501/-Users-ronnyeriksson/6496d059-91c5-49f6-81ad-bd9a8ad802dd/scratchpad/socials-wt/brand/deck/src/images/fullbleed-valerie-june.jpg">    </p:cNvPr>
           <p:cNvPicPr>
             <a:picLocks noChangeAspect="1"/>
           </p:cNvPicPr>

</xml_diff>

<commit_message>
Add TikTok @allthingsodd.co to the socials and the deck
Co-Authored-By: Claude Opus 5.5 <noreply@anthropic.com>
</commit_message>
<xml_diff>
--- a/brand/deck/all-things-odd-template.pptx
+++ b/brand/deck/all-things-odd-template.pptx
@@ -3205,7 +3205,7 @@
       </p:grpSpPr>
       <p:pic>
         <p:nvPicPr>
-          <p:cNvPr id="2" name="Image 0" descr="/private/tmp/claude-501/-Users-ronnyeriksson/6496d059-91c5-49f6-81ad-bd9a8ad802dd/scratchpad/socials-wt/brand/deck/src/images/mosaic-01.jpg">    </p:cNvPr>
+          <p:cNvPr id="2" name="Image 0" descr="/private/tmp/claude-501/-Users-ronnyeriksson/6496d059-91c5-49f6-81ad-bd9a8ad802dd/scratchpad/tiktok-wt/brand/deck/src/images/mosaic-01.jpg">    </p:cNvPr>
           <p:cNvPicPr>
             <a:picLocks noChangeAspect="1"/>
           </p:cNvPicPr>
@@ -3229,7 +3229,7 @@
       </p:pic>
       <p:pic>
         <p:nvPicPr>
-          <p:cNvPr id="3" name="Image 1" descr="/private/tmp/claude-501/-Users-ronnyeriksson/6496d059-91c5-49f6-81ad-bd9a8ad802dd/scratchpad/socials-wt/brand/deck/src/images/mosaic-02.jpg">    </p:cNvPr>
+          <p:cNvPr id="3" name="Image 1" descr="/private/tmp/claude-501/-Users-ronnyeriksson/6496d059-91c5-49f6-81ad-bd9a8ad802dd/scratchpad/tiktok-wt/brand/deck/src/images/mosaic-02.jpg">    </p:cNvPr>
           <p:cNvPicPr>
             <a:picLocks noChangeAspect="1"/>
           </p:cNvPicPr>
@@ -3253,7 +3253,7 @@
       </p:pic>
       <p:pic>
         <p:nvPicPr>
-          <p:cNvPr id="4" name="Image 2" descr="/private/tmp/claude-501/-Users-ronnyeriksson/6496d059-91c5-49f6-81ad-bd9a8ad802dd/scratchpad/socials-wt/brand/deck/src/images/mosaic-03.jpg">    </p:cNvPr>
+          <p:cNvPr id="4" name="Image 2" descr="/private/tmp/claude-501/-Users-ronnyeriksson/6496d059-91c5-49f6-81ad-bd9a8ad802dd/scratchpad/tiktok-wt/brand/deck/src/images/mosaic-03.jpg">    </p:cNvPr>
           <p:cNvPicPr>
             <a:picLocks noChangeAspect="1"/>
           </p:cNvPicPr>
@@ -3277,7 +3277,7 @@
       </p:pic>
       <p:pic>
         <p:nvPicPr>
-          <p:cNvPr id="5" name="Image 3" descr="/private/tmp/claude-501/-Users-ronnyeriksson/6496d059-91c5-49f6-81ad-bd9a8ad802dd/scratchpad/socials-wt/brand/deck/src/images/mosaic-04.jpg">    </p:cNvPr>
+          <p:cNvPr id="5" name="Image 3" descr="/private/tmp/claude-501/-Users-ronnyeriksson/6496d059-91c5-49f6-81ad-bd9a8ad802dd/scratchpad/tiktok-wt/brand/deck/src/images/mosaic-04.jpg">    </p:cNvPr>
           <p:cNvPicPr>
             <a:picLocks noChangeAspect="1"/>
           </p:cNvPicPr>
@@ -3301,7 +3301,7 @@
       </p:pic>
       <p:pic>
         <p:nvPicPr>
-          <p:cNvPr id="6" name="Image 4" descr="/private/tmp/claude-501/-Users-ronnyeriksson/6496d059-91c5-49f6-81ad-bd9a8ad802dd/scratchpad/socials-wt/brand/deck/src/images/mosaic-05.jpg">    </p:cNvPr>
+          <p:cNvPr id="6" name="Image 4" descr="/private/tmp/claude-501/-Users-ronnyeriksson/6496d059-91c5-49f6-81ad-bd9a8ad802dd/scratchpad/tiktok-wt/brand/deck/src/images/mosaic-05.jpg">    </p:cNvPr>
           <p:cNvPicPr>
             <a:picLocks noChangeAspect="1"/>
           </p:cNvPicPr>
@@ -3325,7 +3325,7 @@
       </p:pic>
       <p:pic>
         <p:nvPicPr>
-          <p:cNvPr id="7" name="Image 5" descr="/private/tmp/claude-501/-Users-ronnyeriksson/6496d059-91c5-49f6-81ad-bd9a8ad802dd/scratchpad/socials-wt/brand/deck/src/images/mosaic-06.jpg">    </p:cNvPr>
+          <p:cNvPr id="7" name="Image 5" descr="/private/tmp/claude-501/-Users-ronnyeriksson/6496d059-91c5-49f6-81ad-bd9a8ad802dd/scratchpad/tiktok-wt/brand/deck/src/images/mosaic-06.jpg">    </p:cNvPr>
           <p:cNvPicPr>
             <a:picLocks noChangeAspect="1"/>
           </p:cNvPicPr>
@@ -3349,7 +3349,7 @@
       </p:pic>
       <p:pic>
         <p:nvPicPr>
-          <p:cNvPr id="8" name="Image 6" descr="/private/tmp/claude-501/-Users-ronnyeriksson/6496d059-91c5-49f6-81ad-bd9a8ad802dd/scratchpad/socials-wt/brand/deck/src/images/mosaic-07.jpg">    </p:cNvPr>
+          <p:cNvPr id="8" name="Image 6" descr="/private/tmp/claude-501/-Users-ronnyeriksson/6496d059-91c5-49f6-81ad-bd9a8ad802dd/scratchpad/tiktok-wt/brand/deck/src/images/mosaic-07.jpg">    </p:cNvPr>
           <p:cNvPicPr>
             <a:picLocks noChangeAspect="1"/>
           </p:cNvPicPr>
@@ -3373,7 +3373,7 @@
       </p:pic>
       <p:pic>
         <p:nvPicPr>
-          <p:cNvPr id="9" name="Image 7" descr="/private/tmp/claude-501/-Users-ronnyeriksson/6496d059-91c5-49f6-81ad-bd9a8ad802dd/scratchpad/socials-wt/brand/deck/src/images/mosaic-08.jpg">    </p:cNvPr>
+          <p:cNvPr id="9" name="Image 7" descr="/private/tmp/claude-501/-Users-ronnyeriksson/6496d059-91c5-49f6-81ad-bd9a8ad802dd/scratchpad/tiktok-wt/brand/deck/src/images/mosaic-08.jpg">    </p:cNvPr>
           <p:cNvPicPr>
             <a:picLocks noChangeAspect="1"/>
           </p:cNvPicPr>
@@ -3397,7 +3397,7 @@
       </p:pic>
       <p:pic>
         <p:nvPicPr>
-          <p:cNvPr id="10" name="Image 8" descr="/private/tmp/claude-501/-Users-ronnyeriksson/6496d059-91c5-49f6-81ad-bd9a8ad802dd/scratchpad/socials-wt/brand/deck/src/images/mosaic-09.jpg">    </p:cNvPr>
+          <p:cNvPr id="10" name="Image 8" descr="/private/tmp/claude-501/-Users-ronnyeriksson/6496d059-91c5-49f6-81ad-bd9a8ad802dd/scratchpad/tiktok-wt/brand/deck/src/images/mosaic-09.jpg">    </p:cNvPr>
           <p:cNvPicPr>
             <a:picLocks noChangeAspect="1"/>
           </p:cNvPicPr>
@@ -3421,7 +3421,7 @@
       </p:pic>
       <p:pic>
         <p:nvPicPr>
-          <p:cNvPr id="11" name="Image 9" descr="/private/tmp/claude-501/-Users-ronnyeriksson/6496d059-91c5-49f6-81ad-bd9a8ad802dd/scratchpad/socials-wt/brand/deck/src/images/mosaic-10.jpg">    </p:cNvPr>
+          <p:cNvPr id="11" name="Image 9" descr="/private/tmp/claude-501/-Users-ronnyeriksson/6496d059-91c5-49f6-81ad-bd9a8ad802dd/scratchpad/tiktok-wt/brand/deck/src/images/mosaic-10.jpg">    </p:cNvPr>
           <p:cNvPicPr>
             <a:picLocks noChangeAspect="1"/>
           </p:cNvPicPr>
@@ -3445,7 +3445,7 @@
       </p:pic>
       <p:pic>
         <p:nvPicPr>
-          <p:cNvPr id="12" name="Image 10" descr="/private/tmp/claude-501/-Users-ronnyeriksson/6496d059-91c5-49f6-81ad-bd9a8ad802dd/scratchpad/socials-wt/brand/deck/src/images/mosaic-11.jpg">    </p:cNvPr>
+          <p:cNvPr id="12" name="Image 10" descr="/private/tmp/claude-501/-Users-ronnyeriksson/6496d059-91c5-49f6-81ad-bd9a8ad802dd/scratchpad/tiktok-wt/brand/deck/src/images/mosaic-11.jpg">    </p:cNvPr>
           <p:cNvPicPr>
             <a:picLocks noChangeAspect="1"/>
           </p:cNvPicPr>
@@ -3469,7 +3469,7 @@
       </p:pic>
       <p:pic>
         <p:nvPicPr>
-          <p:cNvPr id="13" name="Image 11" descr="/private/tmp/claude-501/-Users-ronnyeriksson/6496d059-91c5-49f6-81ad-bd9a8ad802dd/scratchpad/socials-wt/brand/deck/src/images/mosaic-12.jpg">    </p:cNvPr>
+          <p:cNvPr id="13" name="Image 11" descr="/private/tmp/claude-501/-Users-ronnyeriksson/6496d059-91c5-49f6-81ad-bd9a8ad802dd/scratchpad/tiktok-wt/brand/deck/src/images/mosaic-12.jpg">    </p:cNvPr>
           <p:cNvPicPr>
             <a:picLocks noChangeAspect="1"/>
           </p:cNvPicPr>
@@ -3515,7 +3515,7 @@
       </p:sp>
       <p:pic>
         <p:nvPicPr>
-          <p:cNvPr id="15" name="Image 12" descr="/private/tmp/claude-501/-Users-ronnyeriksson/6496d059-91c5-49f6-81ad-bd9a8ad802dd/scratchpad/socials-wt/brand/logos/png/odd-mark-paper.png">    </p:cNvPr>
+          <p:cNvPr id="15" name="Image 12" descr="/private/tmp/claude-501/-Users-ronnyeriksson/6496d059-91c5-49f6-81ad-bd9a8ad802dd/scratchpad/tiktok-wt/brand/logos/png/odd-mark-paper.png">    </p:cNvPr>
           <p:cNvPicPr>
             <a:picLocks noChangeAspect="1"/>
           </p:cNvPicPr>
@@ -6020,7 +6020,7 @@
       </p:sp>
       <p:pic>
         <p:nvPicPr>
-          <p:cNvPr id="3" name="Image 0" descr="/private/tmp/claude-501/-Users-ronnyeriksson/6496d059-91c5-49f6-81ad-bd9a8ad802dd/scratchpad/socials-wt/brand/logos/png/odd-mark-paper.png">    </p:cNvPr>
+          <p:cNvPr id="3" name="Image 0" descr="/private/tmp/claude-501/-Users-ronnyeriksson/6496d059-91c5-49f6-81ad-bd9a8ad802dd/scratchpad/tiktok-wt/brand/logos/png/odd-mark-paper.png">    </p:cNvPr>
           <p:cNvPicPr>
             <a:picLocks noChangeAspect="1"/>
           </p:cNvPicPr>
@@ -6221,7 +6221,7 @@
       </p:sp>
       <p:pic>
         <p:nvPicPr>
-          <p:cNvPr id="11" name="Image 1" descr="/private/tmp/claude-501/-Users-ronnyeriksson/6496d059-91c5-49f6-81ad-bd9a8ad802dd/scratchpad/socials-wt/brand/logos/png/oddfest-paper.png">    </p:cNvPr>
+          <p:cNvPr id="11" name="Image 1" descr="/private/tmp/claude-501/-Users-ronnyeriksson/6496d059-91c5-49f6-81ad-bd9a8ad802dd/scratchpad/tiktok-wt/brand/logos/png/oddfest-paper.png">    </p:cNvPr>
           <p:cNvPicPr>
             <a:picLocks noChangeAspect="1"/>
           </p:cNvPicPr>
@@ -6349,7 +6349,7 @@
       </p:sp>
       <p:pic>
         <p:nvPicPr>
-          <p:cNvPr id="15" name="Image 2" descr="/private/tmp/claude-501/-Users-ronnyeriksson/6496d059-91c5-49f6-81ad-bd9a8ad802dd/scratchpad/socials-wt/brand/logos/png/oddference-paper.png">    </p:cNvPr>
+          <p:cNvPr id="15" name="Image 2" descr="/private/tmp/claude-501/-Users-ronnyeriksson/6496d059-91c5-49f6-81ad-bd9a8ad802dd/scratchpad/tiktok-wt/brand/logos/png/oddference-paper.png">    </p:cNvPr>
           <p:cNvPicPr>
             <a:picLocks noChangeAspect="1"/>
           </p:cNvPicPr>
@@ -6477,7 +6477,7 @@
       </p:sp>
       <p:pic>
         <p:nvPicPr>
-          <p:cNvPr id="19" name="Image 3" descr="/private/tmp/claude-501/-Users-ronnyeriksson/6496d059-91c5-49f6-81ad-bd9a8ad802dd/scratchpad/socials-wt/brand/logos/png/oddspace-paper.png">    </p:cNvPr>
+          <p:cNvPr id="19" name="Image 3" descr="/private/tmp/claude-501/-Users-ronnyeriksson/6496d059-91c5-49f6-81ad-bd9a8ad802dd/scratchpad/tiktok-wt/brand/logos/png/oddspace-paper.png">    </p:cNvPr>
           <p:cNvPicPr>
             <a:picLocks noChangeAspect="1"/>
           </p:cNvPicPr>
@@ -7043,7 +7043,7 @@
       </p:sp>
       <p:pic>
         <p:nvPicPr>
-          <p:cNvPr id="7" name="Image 0" descr="/private/tmp/claude-501/-Users-ronnyeriksson/6496d059-91c5-49f6-81ad-bd9a8ad802dd/scratchpad/socials-wt/brand/deck/src/images/partner-moomin.png">    </p:cNvPr>
+          <p:cNvPr id="7" name="Image 0" descr="/private/tmp/claude-501/-Users-ronnyeriksson/6496d059-91c5-49f6-81ad-bd9a8ad802dd/scratchpad/tiktok-wt/brand/deck/src/images/partner-moomin.png">    </p:cNvPr>
           <p:cNvPicPr>
             <a:picLocks noChangeAspect="1"/>
           </p:cNvPicPr>
@@ -7087,7 +7087,7 @@
       </p:sp>
       <p:pic>
         <p:nvPicPr>
-          <p:cNvPr id="9" name="Image 1" descr="/private/tmp/claude-501/-Users-ronnyeriksson/6496d059-91c5-49f6-81ad-bd9a8ad802dd/scratchpad/socials-wt/brand/deck/src/images/partner-genelec.png">    </p:cNvPr>
+          <p:cNvPr id="9" name="Image 1" descr="/private/tmp/claude-501/-Users-ronnyeriksson/6496d059-91c5-49f6-81ad-bd9a8ad802dd/scratchpad/tiktok-wt/brand/deck/src/images/partner-genelec.png">    </p:cNvPr>
           <p:cNvPicPr>
             <a:picLocks noChangeAspect="1"/>
           </p:cNvPicPr>
@@ -7131,7 +7131,7 @@
       </p:sp>
       <p:pic>
         <p:nvPicPr>
-          <p:cNvPr id="11" name="Image 2" descr="/private/tmp/claude-501/-Users-ronnyeriksson/6496d059-91c5-49f6-81ad-bd9a8ad802dd/scratchpad/socials-wt/brand/deck/src/images/partner-holvi.png">    </p:cNvPr>
+          <p:cNvPr id="11" name="Image 2" descr="/private/tmp/claude-501/-Users-ronnyeriksson/6496d059-91c5-49f6-81ad-bd9a8ad802dd/scratchpad/tiktok-wt/brand/deck/src/images/partner-holvi.png">    </p:cNvPr>
           <p:cNvPicPr>
             <a:picLocks noChangeAspect="1"/>
           </p:cNvPicPr>
@@ -7175,7 +7175,7 @@
       </p:sp>
       <p:pic>
         <p:nvPicPr>
-          <p:cNvPr id="13" name="Image 3" descr="/private/tmp/claude-501/-Users-ronnyeriksson/6496d059-91c5-49f6-81ad-bd9a8ad802dd/scratchpad/socials-wt/brand/deck/src/images/partner-tiketti.png">    </p:cNvPr>
+          <p:cNvPr id="13" name="Image 3" descr="/private/tmp/claude-501/-Users-ronnyeriksson/6496d059-91c5-49f6-81ad-bd9a8ad802dd/scratchpad/tiktok-wt/brand/deck/src/images/partner-tiketti.png">    </p:cNvPr>
           <p:cNvPicPr>
             <a:picLocks noChangeAspect="1"/>
           </p:cNvPicPr>
@@ -7219,7 +7219,7 @@
       </p:sp>
       <p:pic>
         <p:nvPicPr>
-          <p:cNvPr id="15" name="Image 4" descr="/private/tmp/claude-501/-Users-ronnyeriksson/6496d059-91c5-49f6-81ad-bd9a8ad802dd/scratchpad/socials-wt/brand/deck/src/images/partner-suomenkulttuurirahasto.png">    </p:cNvPr>
+          <p:cNvPr id="15" name="Image 4" descr="/private/tmp/claude-501/-Users-ronnyeriksson/6496d059-91c5-49f6-81ad-bd9a8ad802dd/scratchpad/tiktok-wt/brand/deck/src/images/partner-suomenkulttuurirahasto.png">    </p:cNvPr>
           <p:cNvPicPr>
             <a:picLocks noChangeAspect="1"/>
           </p:cNvPicPr>
@@ -7263,7 +7263,7 @@
       </p:sp>
       <p:pic>
         <p:nvPicPr>
-          <p:cNvPr id="17" name="Image 5" descr="/private/tmp/claude-501/-Users-ronnyeriksson/6496d059-91c5-49f6-81ad-bd9a8ad802dd/scratchpad/socials-wt/brand/deck/src/images/partner-suomenyrittajat.png">    </p:cNvPr>
+          <p:cNvPr id="17" name="Image 5" descr="/private/tmp/claude-501/-Users-ronnyeriksson/6496d059-91c5-49f6-81ad-bd9a8ad802dd/scratchpad/tiktok-wt/brand/deck/src/images/partner-suomenyrittajat.png">    </p:cNvPr>
           <p:cNvPicPr>
             <a:picLocks noChangeAspect="1"/>
           </p:cNvPicPr>
@@ -7307,7 +7307,7 @@
       </p:sp>
       <p:pic>
         <p:nvPicPr>
-          <p:cNvPr id="19" name="Image 6" descr="/private/tmp/claude-501/-Users-ronnyeriksson/6496d059-91c5-49f6-81ad-bd9a8ad802dd/scratchpad/socials-wt/brand/deck/src/images/partner-suomentekstiilijamuoti.png">    </p:cNvPr>
+          <p:cNvPr id="19" name="Image 6" descr="/private/tmp/claude-501/-Users-ronnyeriksson/6496d059-91c5-49f6-81ad-bd9a8ad802dd/scratchpad/tiktok-wt/brand/deck/src/images/partner-suomentekstiilijamuoti.png">    </p:cNvPr>
           <p:cNvPicPr>
             <a:picLocks noChangeAspect="1"/>
           </p:cNvPicPr>
@@ -7351,7 +7351,7 @@
       </p:sp>
       <p:pic>
         <p:nvPicPr>
-          <p:cNvPr id="21" name="Image 7" descr="/private/tmp/claude-501/-Users-ronnyeriksson/6496d059-91c5-49f6-81ad-bd9a8ad802dd/scratchpad/socials-wt/brand/deck/src/images/partner-yksityisyrittajansaatio.png">    </p:cNvPr>
+          <p:cNvPr id="21" name="Image 7" descr="/private/tmp/claude-501/-Users-ronnyeriksson/6496d059-91c5-49f6-81ad-bd9a8ad802dd/scratchpad/tiktok-wt/brand/deck/src/images/partner-yksityisyrittajansaatio.png">    </p:cNvPr>
           <p:cNvPicPr>
             <a:picLocks noChangeAspect="1"/>
           </p:cNvPicPr>
@@ -7395,7 +7395,7 @@
       </p:sp>
       <p:pic>
         <p:nvPicPr>
-          <p:cNvPr id="23" name="Image 8" descr="/private/tmp/claude-501/-Users-ronnyeriksson/6496d059-91c5-49f6-81ad-bd9a8ad802dd/scratchpad/socials-wt/brand/deck/src/images/partner-eit.png">    </p:cNvPr>
+          <p:cNvPr id="23" name="Image 8" descr="/private/tmp/claude-501/-Users-ronnyeriksson/6496d059-91c5-49f6-81ad-bd9a8ad802dd/scratchpad/tiktok-wt/brand/deck/src/images/partner-eit.png">    </p:cNvPr>
           <p:cNvPicPr>
             <a:picLocks noChangeAspect="1"/>
           </p:cNvPicPr>
@@ -7439,7 +7439,7 @@
       </p:sp>
       <p:pic>
         <p:nvPicPr>
-          <p:cNvPr id="25" name="Image 9" descr="/private/tmp/claude-501/-Users-ronnyeriksson/6496d059-91c5-49f6-81ad-bd9a8ad802dd/scratchpad/socials-wt/brand/deck/src/images/partner-lasipalatsikortteli.png">    </p:cNvPr>
+          <p:cNvPr id="25" name="Image 9" descr="/private/tmp/claude-501/-Users-ronnyeriksson/6496d059-91c5-49f6-81ad-bd9a8ad802dd/scratchpad/tiktok-wt/brand/deck/src/images/partner-lasipalatsikortteli.png">    </p:cNvPr>
           <p:cNvPicPr>
             <a:picLocks noChangeAspect="1"/>
           </p:cNvPicPr>
@@ -7483,7 +7483,7 @@
       </p:sp>
       <p:pic>
         <p:nvPicPr>
-          <p:cNvPr id="27" name="Image 10" descr="/private/tmp/claude-501/-Users-ronnyeriksson/6496d059-91c5-49f6-81ad-bd9a8ad802dd/scratchpad/socials-wt/brand/deck/src/images/partner-kauppakamari.png">    </p:cNvPr>
+          <p:cNvPr id="27" name="Image 10" descr="/private/tmp/claude-501/-Users-ronnyeriksson/6496d059-91c5-49f6-81ad-bd9a8ad802dd/scratchpad/tiktok-wt/brand/deck/src/images/partner-kauppakamari.png">    </p:cNvPr>
           <p:cNvPicPr>
             <a:picLocks noChangeAspect="1"/>
           </p:cNvPicPr>
@@ -7527,7 +7527,7 @@
       </p:sp>
       <p:pic>
         <p:nvPicPr>
-          <p:cNvPr id="29" name="Image 11" descr="/private/tmp/claude-501/-Users-ronnyeriksson/6496d059-91c5-49f6-81ad-bd9a8ad802dd/scratchpad/socials-wt/brand/deck/src/images/partner-helsinkiplayground.png">    </p:cNvPr>
+          <p:cNvPr id="29" name="Image 11" descr="/private/tmp/claude-501/-Users-ronnyeriksson/6496d059-91c5-49f6-81ad-bd9a8ad802dd/scratchpad/tiktok-wt/brand/deck/src/images/partner-helsinkiplayground.png">    </p:cNvPr>
           <p:cNvPicPr>
             <a:picLocks noChangeAspect="1"/>
           </p:cNvPicPr>
@@ -7571,7 +7571,7 @@
       </p:sp>
       <p:pic>
         <p:nvPicPr>
-          <p:cNvPr id="31" name="Image 12" descr="/private/tmp/claude-501/-Users-ronnyeriksson/6496d059-91c5-49f6-81ad-bd9a8ad802dd/scratchpad/socials-wt/brand/deck/src/images/partner-helsinkicasting.png">    </p:cNvPr>
+          <p:cNvPr id="31" name="Image 12" descr="/private/tmp/claude-501/-Users-ronnyeriksson/6496d059-91c5-49f6-81ad-bd9a8ad802dd/scratchpad/tiktok-wt/brand/deck/src/images/partner-helsinkicasting.png">    </p:cNvPr>
           <p:cNvPicPr>
             <a:picLocks noChangeAspect="1"/>
           </p:cNvPicPr>
@@ -7615,7 +7615,7 @@
       </p:sp>
       <p:pic>
         <p:nvPicPr>
-          <p:cNvPr id="33" name="Image 13" descr="/private/tmp/claude-501/-Users-ronnyeriksson/6496d059-91c5-49f6-81ad-bd9a8ad802dd/scratchpad/socials-wt/brand/deck/src/images/partner-radicalcreativity.png">    </p:cNvPr>
+          <p:cNvPr id="33" name="Image 13" descr="/private/tmp/claude-501/-Users-ronnyeriksson/6496d059-91c5-49f6-81ad-bd9a8ad802dd/scratchpad/tiktok-wt/brand/deck/src/images/partner-radicalcreativity.png">    </p:cNvPr>
           <p:cNvPicPr>
             <a:picLocks noChangeAspect="1"/>
           </p:cNvPicPr>
@@ -7659,7 +7659,7 @@
       </p:sp>
       <p:pic>
         <p:nvPicPr>
-          <p:cNvPr id="35" name="Image 14" descr="/private/tmp/claude-501/-Users-ronnyeriksson/6496d059-91c5-49f6-81ad-bd9a8ad802dd/scratchpad/socials-wt/brand/deck/src/images/partner-adventureclub.png">    </p:cNvPr>
+          <p:cNvPr id="35" name="Image 14" descr="/private/tmp/claude-501/-Users-ronnyeriksson/6496d059-91c5-49f6-81ad-bd9a8ad802dd/scratchpad/tiktok-wt/brand/deck/src/images/partner-adventureclub.png">    </p:cNvPr>
           <p:cNvPicPr>
             <a:picLocks noChangeAspect="1"/>
           </p:cNvPicPr>
@@ -7703,7 +7703,7 @@
       </p:sp>
       <p:pic>
         <p:nvPicPr>
-          <p:cNvPr id="37" name="Image 15" descr="/private/tmp/claude-501/-Users-ronnyeriksson/6496d059-91c5-49f6-81ad-bd9a8ad802dd/scratchpad/socials-wt/brand/deck/src/images/partner-prodjfinland.png">    </p:cNvPr>
+          <p:cNvPr id="37" name="Image 15" descr="/private/tmp/claude-501/-Users-ronnyeriksson/6496d059-91c5-49f6-81ad-bd9a8ad802dd/scratchpad/tiktok-wt/brand/deck/src/images/partner-prodjfinland.png">    </p:cNvPr>
           <p:cNvPicPr>
             <a:picLocks noChangeAspect="1"/>
           </p:cNvPicPr>
@@ -7747,7 +7747,7 @@
       </p:sp>
       <p:pic>
         <p:nvPicPr>
-          <p:cNvPr id="39" name="Image 16" descr="/private/tmp/claude-501/-Users-ronnyeriksson/6496d059-91c5-49f6-81ad-bd9a8ad802dd/scratchpad/socials-wt/brand/deck/src/images/partner-dottir.png">    </p:cNvPr>
+          <p:cNvPr id="39" name="Image 16" descr="/private/tmp/claude-501/-Users-ronnyeriksson/6496d059-91c5-49f6-81ad-bd9a8ad802dd/scratchpad/tiktok-wt/brand/deck/src/images/partner-dottir.png">    </p:cNvPr>
           <p:cNvPicPr>
             <a:picLocks noChangeAspect="1"/>
           </p:cNvPicPr>
@@ -7791,7 +7791,7 @@
       </p:sp>
       <p:pic>
         <p:nvPicPr>
-          <p:cNvPr id="41" name="Image 17" descr="/private/tmp/claude-501/-Users-ronnyeriksson/6496d059-91c5-49f6-81ad-bd9a8ad802dd/scratchpad/socials-wt/brand/deck/src/images/partner-liwlig.png">    </p:cNvPr>
+          <p:cNvPr id="41" name="Image 17" descr="/private/tmp/claude-501/-Users-ronnyeriksson/6496d059-91c5-49f6-81ad-bd9a8ad802dd/scratchpad/tiktok-wt/brand/deck/src/images/partner-liwlig.png">    </p:cNvPr>
           <p:cNvPicPr>
             <a:picLocks noChangeAspect="1"/>
           </p:cNvPicPr>
@@ -7835,7 +7835,7 @@
       </p:sp>
       <p:pic>
         <p:nvPicPr>
-          <p:cNvPr id="43" name="Image 18" descr="/private/tmp/claude-501/-Users-ronnyeriksson/6496d059-91c5-49f6-81ad-bd9a8ad802dd/scratchpad/socials-wt/brand/deck/src/images/partner-latorrefazione.png">    </p:cNvPr>
+          <p:cNvPr id="43" name="Image 18" descr="/private/tmp/claude-501/-Users-ronnyeriksson/6496d059-91c5-49f6-81ad-bd9a8ad802dd/scratchpad/tiktok-wt/brand/deck/src/images/partner-latorrefazione.png">    </p:cNvPr>
           <p:cNvPicPr>
             <a:picLocks noChangeAspect="1"/>
           </p:cNvPicPr>
@@ -7879,7 +7879,7 @@
       </p:sp>
       <p:pic>
         <p:nvPicPr>
-          <p:cNvPr id="45" name="Image 19" descr="/private/tmp/claude-501/-Users-ronnyeriksson/6496d059-91c5-49f6-81ad-bd9a8ad802dd/scratchpad/socials-wt/brand/deck/src/images/partner-uneton.png">    </p:cNvPr>
+          <p:cNvPr id="45" name="Image 19" descr="/private/tmp/claude-501/-Users-ronnyeriksson/6496d059-91c5-49f6-81ad-bd9a8ad802dd/scratchpad/tiktok-wt/brand/deck/src/images/partner-uneton.png">    </p:cNvPr>
           <p:cNvPicPr>
             <a:picLocks noChangeAspect="1"/>
           </p:cNvPicPr>
@@ -7923,7 +7923,7 @@
       </p:sp>
       <p:pic>
         <p:nvPicPr>
-          <p:cNvPr id="47" name="Image 20" descr="/private/tmp/claude-501/-Users-ronnyeriksson/6496d059-91c5-49f6-81ad-bd9a8ad802dd/scratchpad/socials-wt/brand/deck/src/images/partner-sanfrancisco.png">    </p:cNvPr>
+          <p:cNvPr id="47" name="Image 20" descr="/private/tmp/claude-501/-Users-ronnyeriksson/6496d059-91c5-49f6-81ad-bd9a8ad802dd/scratchpad/tiktok-wt/brand/deck/src/images/partner-sanfrancisco.png">    </p:cNvPr>
           <p:cNvPicPr>
             <a:picLocks noChangeAspect="1"/>
           </p:cNvPicPr>
@@ -7967,7 +7967,7 @@
       </p:sp>
       <p:pic>
         <p:nvPicPr>
-          <p:cNvPr id="49" name="Image 21" descr="/private/tmp/claude-501/-Users-ronnyeriksson/6496d059-91c5-49f6-81ad-bd9a8ad802dd/scratchpad/socials-wt/brand/deck/src/images/partner-tresmeder.png">    </p:cNvPr>
+          <p:cNvPr id="49" name="Image 21" descr="/private/tmp/claude-501/-Users-ronnyeriksson/6496d059-91c5-49f6-81ad-bd9a8ad802dd/scratchpad/tiktok-wt/brand/deck/src/images/partner-tresmeder.png">    </p:cNvPr>
           <p:cNvPicPr>
             <a:picLocks noChangeAspect="1"/>
           </p:cNvPicPr>
@@ -8275,7 +8275,7 @@
       </p:sp>
       <p:pic>
         <p:nvPicPr>
-          <p:cNvPr id="7" name="Image 0" descr="/private/tmp/claude-501/-Users-ronnyeriksson/6496d059-91c5-49f6-81ad-bd9a8ad802dd/scratchpad/socials-wt/brand/deck/src/images/speaker-sanna-kaisa-niikko.jpg">    </p:cNvPr>
+          <p:cNvPr id="7" name="Image 0" descr="/private/tmp/claude-501/-Users-ronnyeriksson/6496d059-91c5-49f6-81ad-bd9a8ad802dd/scratchpad/tiktok-wt/brand/deck/src/images/speaker-sanna-kaisa-niikko.jpg">    </p:cNvPr>
           <p:cNvPicPr>
             <a:picLocks noChangeAspect="1"/>
           </p:cNvPicPr>
@@ -8403,7 +8403,7 @@
       </p:sp>
       <p:pic>
         <p:nvPicPr>
-          <p:cNvPr id="11" name="Image 1" descr="/private/tmp/claude-501/-Users-ronnyeriksson/6496d059-91c5-49f6-81ad-bd9a8ad802dd/scratchpad/socials-wt/brand/deck/src/images/speaker-siamak-naghian.jpg">    </p:cNvPr>
+          <p:cNvPr id="11" name="Image 1" descr="/private/tmp/claude-501/-Users-ronnyeriksson/6496d059-91c5-49f6-81ad-bd9a8ad802dd/scratchpad/tiktok-wt/brand/deck/src/images/speaker-siamak-naghian.jpg">    </p:cNvPr>
           <p:cNvPicPr>
             <a:picLocks noChangeAspect="1"/>
           </p:cNvPicPr>
@@ -8531,7 +8531,7 @@
       </p:sp>
       <p:pic>
         <p:nvPicPr>
-          <p:cNvPr id="15" name="Image 2" descr="/private/tmp/claude-501/-Users-ronnyeriksson/6496d059-91c5-49f6-81ad-bd9a8ad802dd/scratchpad/socials-wt/brand/deck/src/images/speaker-ashley-jex-wagner.jpg">    </p:cNvPr>
+          <p:cNvPr id="15" name="Image 2" descr="/private/tmp/claude-501/-Users-ronnyeriksson/6496d059-91c5-49f6-81ad-bd9a8ad802dd/scratchpad/tiktok-wt/brand/deck/src/images/speaker-ashley-jex-wagner.jpg">    </p:cNvPr>
           <p:cNvPicPr>
             <a:picLocks noChangeAspect="1"/>
           </p:cNvPicPr>
@@ -8659,7 +8659,7 @@
       </p:sp>
       <p:pic>
         <p:nvPicPr>
-          <p:cNvPr id="19" name="Image 3" descr="/private/tmp/claude-501/-Users-ronnyeriksson/6496d059-91c5-49f6-81ad-bd9a8ad802dd/scratchpad/socials-wt/brand/deck/src/images/speaker-atte-jaaskelainen.jpg">    </p:cNvPr>
+          <p:cNvPr id="19" name="Image 3" descr="/private/tmp/claude-501/-Users-ronnyeriksson/6496d059-91c5-49f6-81ad-bd9a8ad802dd/scratchpad/tiktok-wt/brand/deck/src/images/speaker-atte-jaaskelainen.jpg">    </p:cNvPr>
           <p:cNvPicPr>
             <a:picLocks noChangeAspect="1"/>
           </p:cNvPicPr>
@@ -8787,7 +8787,7 @@
       </p:sp>
       <p:pic>
         <p:nvPicPr>
-          <p:cNvPr id="23" name="Image 4" descr="/private/tmp/claude-501/-Users-ronnyeriksson/6496d059-91c5-49f6-81ad-bd9a8ad802dd/scratchpad/socials-wt/brand/deck/src/images/speaker-perttu-polonen.jpg">    </p:cNvPr>
+          <p:cNvPr id="23" name="Image 4" descr="/private/tmp/claude-501/-Users-ronnyeriksson/6496d059-91c5-49f6-81ad-bd9a8ad802dd/scratchpad/tiktok-wt/brand/deck/src/images/speaker-perttu-polonen.jpg">    </p:cNvPr>
           <p:cNvPicPr>
             <a:picLocks noChangeAspect="1"/>
           </p:cNvPicPr>
@@ -8915,7 +8915,7 @@
       </p:sp>
       <p:pic>
         <p:nvPicPr>
-          <p:cNvPr id="27" name="Image 5" descr="/private/tmp/claude-501/-Users-ronnyeriksson/6496d059-91c5-49f6-81ad-bd9a8ad802dd/scratchpad/socials-wt/brand/deck/src/images/speaker-galit-ariel.jpg">    </p:cNvPr>
+          <p:cNvPr id="27" name="Image 5" descr="/private/tmp/claude-501/-Users-ronnyeriksson/6496d059-91c5-49f6-81ad-bd9a8ad802dd/scratchpad/tiktok-wt/brand/deck/src/images/speaker-galit-ariel.jpg">    </p:cNvPr>
           <p:cNvPicPr>
             <a:picLocks noChangeAspect="1"/>
           </p:cNvPicPr>
@@ -9043,7 +9043,7 @@
       </p:sp>
       <p:pic>
         <p:nvPicPr>
-          <p:cNvPr id="31" name="Image 6" descr="/private/tmp/claude-501/-Users-ronnyeriksson/6496d059-91c5-49f6-81ad-bd9a8ad802dd/scratchpad/socials-wt/brand/deck/src/images/speaker-alf-rehn.jpg">    </p:cNvPr>
+          <p:cNvPr id="31" name="Image 6" descr="/private/tmp/claude-501/-Users-ronnyeriksson/6496d059-91c5-49f6-81ad-bd9a8ad802dd/scratchpad/tiktok-wt/brand/deck/src/images/speaker-alf-rehn.jpg">    </p:cNvPr>
           <p:cNvPicPr>
             <a:picLocks noChangeAspect="1"/>
           </p:cNvPicPr>
@@ -9171,7 +9171,7 @@
       </p:sp>
       <p:pic>
         <p:nvPicPr>
-          <p:cNvPr id="35" name="Image 7" descr="/private/tmp/claude-501/-Users-ronnyeriksson/6496d059-91c5-49f6-81ad-bd9a8ad802dd/scratchpad/socials-wt/brand/deck/src/images/speaker-rolf-ekroth.jpg">    </p:cNvPr>
+          <p:cNvPr id="35" name="Image 7" descr="/private/tmp/claude-501/-Users-ronnyeriksson/6496d059-91c5-49f6-81ad-bd9a8ad802dd/scratchpad/tiktok-wt/brand/deck/src/images/speaker-rolf-ekroth.jpg">    </p:cNvPr>
           <p:cNvPicPr>
             <a:picLocks noChangeAspect="1"/>
           </p:cNvPicPr>
@@ -9299,7 +9299,7 @@
       </p:sp>
       <p:pic>
         <p:nvPicPr>
-          <p:cNvPr id="39" name="Image 8" descr="/private/tmp/claude-501/-Users-ronnyeriksson/6496d059-91c5-49f6-81ad-bd9a8ad802dd/scratchpad/socials-wt/brand/deck/src/images/speaker-samppa-lappalainen.jpg">    </p:cNvPr>
+          <p:cNvPr id="39" name="Image 8" descr="/private/tmp/claude-501/-Users-ronnyeriksson/6496d059-91c5-49f6-81ad-bd9a8ad802dd/scratchpad/tiktok-wt/brand/deck/src/images/speaker-samppa-lappalainen.jpg">    </p:cNvPr>
           <p:cNvPicPr>
             <a:picLocks noChangeAspect="1"/>
           </p:cNvPicPr>
@@ -9427,7 +9427,7 @@
       </p:sp>
       <p:pic>
         <p:nvPicPr>
-          <p:cNvPr id="43" name="Image 9" descr="/private/tmp/claude-501/-Users-ronnyeriksson/6496d059-91c5-49f6-81ad-bd9a8ad802dd/scratchpad/socials-wt/brand/deck/src/images/speaker-anna-brchisky.jpg">    </p:cNvPr>
+          <p:cNvPr id="43" name="Image 9" descr="/private/tmp/claude-501/-Users-ronnyeriksson/6496d059-91c5-49f6-81ad-bd9a8ad802dd/scratchpad/tiktok-wt/brand/deck/src/images/speaker-anna-brchisky.jpg">    </p:cNvPr>
           <p:cNvPicPr>
             <a:picLocks noChangeAspect="1"/>
           </p:cNvPicPr>
@@ -10619,7 +10619,7 @@
       </p:sp>
       <p:pic>
         <p:nvPicPr>
-          <p:cNvPr id="3" name="Image 0" descr="/private/tmp/claude-501/-Users-ronnyeriksson/6496d059-91c5-49f6-81ad-bd9a8ad802dd/scratchpad/socials-wt/brand/deck/src/images/case-odd-deep-space.jpg">    </p:cNvPr>
+          <p:cNvPr id="3" name="Image 0" descr="/private/tmp/claude-501/-Users-ronnyeriksson/6496d059-91c5-49f6-81ad-bd9a8ad802dd/scratchpad/tiktok-wt/brand/deck/src/images/case-odd-deep-space.jpg">    </p:cNvPr>
           <p:cNvPicPr>
             <a:picLocks noChangeAspect="1"/>
           </p:cNvPicPr>
@@ -10982,7 +10982,7 @@
       </p:sp>
       <p:pic>
         <p:nvPicPr>
-          <p:cNvPr id="3" name="Image 0" descr="/private/tmp/claude-501/-Users-ronnyeriksson/6496d059-91c5-49f6-81ad-bd9a8ad802dd/scratchpad/socials-wt/brand/deck/src/images/strip-creative.jpg">    </p:cNvPr>
+          <p:cNvPr id="3" name="Image 0" descr="/private/tmp/claude-501/-Users-ronnyeriksson/6496d059-91c5-49f6-81ad-bd9a8ad802dd/scratchpad/tiktok-wt/brand/deck/src/images/strip-creative.jpg">    </p:cNvPr>
           <p:cNvPicPr>
             <a:picLocks noChangeAspect="1"/>
           </p:cNvPicPr>
@@ -11006,7 +11006,7 @@
       </p:pic>
       <p:pic>
         <p:nvPicPr>
-          <p:cNvPr id="4" name="Image 1" descr="/private/tmp/claude-501/-Users-ronnyeriksson/6496d059-91c5-49f6-81ad-bd9a8ad802dd/scratchpad/socials-wt/brand/deck/src/images/strip-business.jpg">    </p:cNvPr>
+          <p:cNvPr id="4" name="Image 1" descr="/private/tmp/claude-501/-Users-ronnyeriksson/6496d059-91c5-49f6-81ad-bd9a8ad802dd/scratchpad/tiktok-wt/brand/deck/src/images/strip-business.jpg">    </p:cNvPr>
           <p:cNvPicPr>
             <a:picLocks noChangeAspect="1"/>
           </p:cNvPicPr>
@@ -12006,7 +12006,7 @@
       </p:grpSpPr>
       <p:pic>
         <p:nvPicPr>
-          <p:cNvPr id="2" name="Image 0" descr="/private/tmp/claude-501/-Users-ronnyeriksson/6496d059-91c5-49f6-81ad-bd9a8ad802dd/scratchpad/socials-wt/brand/logos/png/odd-mark-ink.png">    </p:cNvPr>
+          <p:cNvPr id="2" name="Image 0" descr="/private/tmp/claude-501/-Users-ronnyeriksson/6496d059-91c5-49f6-81ad-bd9a8ad802dd/scratchpad/tiktok-wt/brand/logos/png/odd-mark-ink.png">    </p:cNvPr>
           <p:cNvPicPr>
             <a:picLocks noChangeAspect="1"/>
           </p:cNvPicPr>
@@ -12313,7 +12313,7 @@
       </p:sp>
       <p:pic>
         <p:nvPicPr>
-          <p:cNvPr id="3" name="Image 0" descr="/private/tmp/claude-501/-Users-ronnyeriksson/6496d059-91c5-49f6-81ad-bd9a8ad802dd/scratchpad/socials-wt/brand/logos/png/odd-mark-ink.png">    </p:cNvPr>
+          <p:cNvPr id="3" name="Image 0" descr="/private/tmp/claude-501/-Users-ronnyeriksson/6496d059-91c5-49f6-81ad-bd9a8ad802dd/scratchpad/tiktok-wt/brand/logos/png/odd-mark-ink.png">    </p:cNvPr>
           <p:cNvPicPr>
             <a:picLocks noChangeAspect="1"/>
           </p:cNvPicPr>
@@ -13170,7 +13170,7 @@
                 <a:ea typeface="Gabarito SemiBold" pitchFamily="34" charset="-122"/>
                 <a:cs typeface="Gabarito SemiBold" pitchFamily="34" charset="-120"/>
               </a:rPr>
-              <a:t>NEWSLETTER</a:t>
+              <a:t>TIKTOK</a:t>
             </a:r>
             <a:endParaRPr lang="en-US" sz="1400" dirty="0"/>
           </a:p>
@@ -13212,7 +13212,7 @@
                 <a:ea typeface="Gabarito" pitchFamily="34" charset="-122"/>
                 <a:cs typeface="Gabarito" pitchFamily="34" charset="-120"/>
               </a:rPr>
-              <a:t>oddfest.beehiiv.com</a:t>
+              <a:t>@allthingsodd.co</a:t>
             </a:r>
             <a:endParaRPr lang="en-US" sz="1800" dirty="0"/>
           </a:p>
@@ -13244,6 +13244,113 @@
       <p:sp>
         <p:nvSpPr>
           <p:cNvPr id="29" name="Text 26"/>
+          <p:cNvSpPr txBox="1"/>
+          <p:nvPr/>
+        </p:nvSpPr>
+        <p:spPr>
+          <a:xfrm>
+            <a:off x="6210148" y="5971032"/>
+            <a:ext cx="1650949" cy="201168"/>
+          </a:xfrm>
+          <a:prstGeom prst="rect">
+            <a:avLst/>
+          </a:prstGeom>
+          <a:noFill/>
+          <a:ln/>
+        </p:spPr>
+        <p:txBody>
+          <a:bodyPr wrap="square" lIns="0" tIns="0" rIns="0" bIns="0" rtlCol="0" anchor="t"/>
+          <a:lstStyle/>
+          <a:p>
+            <a:pPr algn="l" indent="0" marL="0">
+              <a:lnSpc>
+                <a:spcPts val="1900"/>
+              </a:lnSpc>
+              <a:buNone/>
+            </a:pPr>
+            <a:r>
+              <a:rPr lang="en-US" sz="1400" spc="220" kern="0" dirty="0">
+                <a:solidFill>
+                  <a:srgbClr val="5F5A5B"/>
+                </a:solidFill>
+                <a:latin typeface="Gabarito SemiBold" pitchFamily="34" charset="0"/>
+                <a:ea typeface="Gabarito SemiBold" pitchFamily="34" charset="-122"/>
+                <a:cs typeface="Gabarito SemiBold" pitchFamily="34" charset="-120"/>
+              </a:rPr>
+              <a:t>NEWSLETTER</a:t>
+            </a:r>
+            <a:endParaRPr lang="en-US" sz="1400" dirty="0"/>
+          </a:p>
+        </p:txBody>
+      </p:sp>
+      <p:sp>
+        <p:nvSpPr>
+          <p:cNvPr id="30" name="Text 27"/>
+          <p:cNvSpPr txBox="1"/>
+          <p:nvPr/>
+        </p:nvSpPr>
+        <p:spPr>
+          <a:xfrm>
+            <a:off x="8089697" y="5934456"/>
+            <a:ext cx="3530498" cy="274320"/>
+          </a:xfrm>
+          <a:prstGeom prst="rect">
+            <a:avLst/>
+          </a:prstGeom>
+          <a:noFill/>
+          <a:ln/>
+        </p:spPr>
+        <p:txBody>
+          <a:bodyPr wrap="square" lIns="0" tIns="0" rIns="0" bIns="0" rtlCol="0" anchor="t"/>
+          <a:lstStyle/>
+          <a:p>
+            <a:pPr indent="0" marL="0">
+              <a:lnSpc>
+                <a:spcPts val="2500"/>
+              </a:lnSpc>
+              <a:buNone/>
+            </a:pPr>
+            <a:r>
+              <a:rPr lang="en-US" sz="1800" dirty="0">
+                <a:solidFill>
+                  <a:srgbClr val="0E090B"/>
+                </a:solidFill>
+                <a:latin typeface="Gabarito" pitchFamily="34" charset="0"/>
+                <a:ea typeface="Gabarito" pitchFamily="34" charset="-122"/>
+                <a:cs typeface="Gabarito" pitchFamily="34" charset="-120"/>
+              </a:rPr>
+              <a:t>oddfest.beehiiv.com</a:t>
+            </a:r>
+            <a:endParaRPr lang="en-US" sz="1800" dirty="0"/>
+          </a:p>
+        </p:txBody>
+      </p:sp>
+      <p:sp>
+        <p:nvSpPr>
+          <p:cNvPr id="31" name="Shape 28"/>
+          <p:cNvSpPr/>
+          <p:nvPr/>
+        </p:nvSpPr>
+        <p:spPr>
+          <a:xfrm>
+            <a:off x="6210148" y="6409944"/>
+            <a:ext cx="5410048" cy="0"/>
+          </a:xfrm>
+          <a:prstGeom prst="line">
+            <a:avLst/>
+          </a:prstGeom>
+          <a:noFill/>
+          <a:ln w="9525">
+            <a:solidFill>
+              <a:srgbClr val="C9C5C5"/>
+            </a:solidFill>
+            <a:prstDash val="solid"/>
+          </a:ln>
+        </p:spPr>
+      </p:sp>
+      <p:sp>
+        <p:nvSpPr>
+          <p:cNvPr id="32" name="Text 29"/>
           <p:cNvSpPr txBox="1"/>
           <p:nvPr/>
         </p:nvSpPr>
@@ -13716,7 +13823,7 @@
       </p:sp>
       <p:pic>
         <p:nvPicPr>
-          <p:cNvPr id="3" name="Image 0" descr="/private/tmp/claude-501/-Users-ronnyeriksson/6496d059-91c5-49f6-81ad-bd9a8ad802dd/scratchpad/socials-wt/brand/logos/png/odd-mark-paper.png">    </p:cNvPr>
+          <p:cNvPr id="3" name="Image 0" descr="/private/tmp/claude-501/-Users-ronnyeriksson/6496d059-91c5-49f6-81ad-bd9a8ad802dd/scratchpad/tiktok-wt/brand/logos/png/odd-mark-paper.png">    </p:cNvPr>
           <p:cNvPicPr>
             <a:picLocks noChangeAspect="1"/>
           </p:cNvPicPr>
@@ -14434,7 +14541,7 @@
       </p:sp>
       <p:pic>
         <p:nvPicPr>
-          <p:cNvPr id="3" name="Image 0" descr="/private/tmp/claude-501/-Users-ronnyeriksson/6496d059-91c5-49f6-81ad-bd9a8ad802dd/scratchpad/socials-wt/brand/deck/src/images/oddfest-oddtheatre.jpg">    </p:cNvPr>
+          <p:cNvPr id="3" name="Image 0" descr="/private/tmp/claude-501/-Users-ronnyeriksson/6496d059-91c5-49f6-81ad-bd9a8ad802dd/scratchpad/tiktok-wt/brand/deck/src/images/oddfest-oddtheatre.jpg">    </p:cNvPr>
           <p:cNvPicPr>
             <a:picLocks noChangeAspect="1"/>
           </p:cNvPicPr>
@@ -14749,7 +14856,7 @@
       </p:sp>
       <p:pic>
         <p:nvPicPr>
-          <p:cNvPr id="3" name="Image 0" descr="/private/tmp/claude-501/-Users-ronnyeriksson/6496d059-91c5-49f6-81ad-bd9a8ad802dd/scratchpad/socials-wt/brand/deck/src/images/oddference-stage.jpg">    </p:cNvPr>
+          <p:cNvPr id="3" name="Image 0" descr="/private/tmp/claude-501/-Users-ronnyeriksson/6496d059-91c5-49f6-81ad-bd9a8ad802dd/scratchpad/tiktok-wt/brand/deck/src/images/oddference-stage.jpg">    </p:cNvPr>
           <p:cNvPicPr>
             <a:picLocks noChangeAspect="1"/>
           </p:cNvPicPr>
@@ -15005,7 +15112,7 @@
       </p:grpSpPr>
       <p:pic>
         <p:nvPicPr>
-          <p:cNvPr id="2" name="Image 0" descr="/private/tmp/claude-501/-Users-ronnyeriksson/6496d059-91c5-49f6-81ad-bd9a8ad802dd/scratchpad/socials-wt/brand/deck/src/images/fullbleed-valerie-june.jpg">    </p:cNvPr>
+          <p:cNvPr id="2" name="Image 0" descr="/private/tmp/claude-501/-Users-ronnyeriksson/6496d059-91c5-49f6-81ad-bd9a8ad802dd/scratchpad/tiktok-wt/brand/deck/src/images/fullbleed-valerie-june.jpg">    </p:cNvPr>
           <p:cNvPicPr>
             <a:picLocks noChangeAspect="1"/>
           </p:cNvPicPr>

</xml_diff>